<commit_message>
Update ORK Technical Presentation with professional animations and closing slide
</commit_message>
<xml_diff>
--- a/ORK_Technical_Deck.pptx
+++ b/ORK_Technical_Deck.pptx
@@ -15,9 +15,10 @@
     <p:sldId id="263" r:id="rId9"/>
     <p:sldId id="264" r:id="rId10"/>
     <p:sldId id="265" r:id="rId11"/>
+    <p:sldId id="266" r:id="rId12"/>
   </p:sldIdLst>
   <p:notesMasterIdLst>
-    <p:notesMasterId r:id="rId12"/>
+    <p:notesMasterId r:id="rId13"/>
   </p:notesMasterIdLst>
   <p:sldSz cx="9144000" cy="5143500"/>
   <p:notesSz cx="5143500" cy="9144000"/>
@@ -623,6 +624,94 @@
             <a:fld id="{F7021451-1387-4CA6-816F-3879F97B5CBC}" type="slidenum">
               <a:rPr lang="en-US"/>
               <a:t>10</a:t>
+            </a:fld>
+            <a:endParaRPr lang="en-US"/>
+          </a:p>
+        </p:txBody>
+      </p:sp>
+    </p:spTree>
+    <p:extLst>
+      <p:ext uri="{BB962C8B-B14F-4D97-AF65-F5344CB8AC3E}">
+        <p14:creationId xmlns:p14="http://schemas.microsoft.com/office/powerpoint/2010/main" val="1024086991"/>
+      </p:ext>
+    </p:extLst>
+  </p:cSld>
+  <p:clrMapOvr>
+    <a:masterClrMapping/>
+  </p:clrMapOvr>
+</p:notes>
+</file>
+
+<file path=ppt/notesSlides/notesSlide11.xml><?xml version="1.0" encoding="utf-8"?>
+<p:notes xmlns:a="http://schemas.openxmlformats.org/drawingml/2006/main" xmlns:r="http://schemas.openxmlformats.org/officeDocument/2006/relationships" xmlns:p="http://schemas.openxmlformats.org/presentationml/2006/main">
+  <p:cSld>
+    <p:spTree>
+      <p:nvGrpSpPr>
+        <p:cNvPr id="1" name=""/>
+        <p:cNvGrpSpPr/>
+        <p:nvPr/>
+      </p:nvGrpSpPr>
+      <p:grpSpPr>
+        <a:xfrm>
+          <a:off x="0" y="0"/>
+          <a:ext cx="0" cy="0"/>
+          <a:chOff x="0" y="0"/>
+          <a:chExt cx="0" cy="0"/>
+        </a:xfrm>
+      </p:grpSpPr>
+      <p:sp>
+        <p:nvSpPr>
+          <p:cNvPr id="2" name="Slide Image Placeholder 1"/>
+          <p:cNvSpPr>
+            <a:spLocks noGrp="1" noRot="1" noChangeAspect="1"/>
+          </p:cNvSpPr>
+          <p:nvPr>
+            <p:ph type="sldImg"/>
+          </p:nvPr>
+        </p:nvSpPr>
+        <p:spPr/>
+      </p:sp>
+      <p:sp>
+        <p:nvSpPr>
+          <p:cNvPr id="3" name="Notes Placeholder 2"/>
+          <p:cNvSpPr>
+            <a:spLocks noGrp="1"/>
+          </p:cNvSpPr>
+          <p:nvPr>
+            <p:ph type="body" idx="1"/>
+          </p:nvPr>
+        </p:nvSpPr>
+        <p:spPr/>
+        <p:txBody>
+          <a:bodyPr/>
+          <a:lstStyle/>
+          <a:p>
+            <a:r>
+              <a:rPr lang="en-US" dirty="0"/>
+              <a:t/>
+            </a:r>
+            <a:endParaRPr lang="en-US" dirty="0"/>
+          </a:p>
+        </p:txBody>
+      </p:sp>
+      <p:sp>
+        <p:nvSpPr>
+          <p:cNvPr id="4" name="Slide Number Placeholder 3"/>
+          <p:cNvSpPr>
+            <a:spLocks noGrp="1"/>
+          </p:cNvSpPr>
+          <p:nvPr>
+            <p:ph type="sldNum" sz="quarter" idx="10"/>
+          </p:nvPr>
+        </p:nvSpPr>
+        <p:spPr/>
+        <p:txBody>
+          <a:bodyPr/>
+          <a:lstStyle/>
+          <a:p>
+            <a:fld id="{F7021451-1387-4CA6-816F-3879F97B5CBC}" type="slidenum">
+              <a:rPr lang="en-US"/>
+              <a:t>11</a:t>
             </a:fld>
             <a:endParaRPr lang="en-US"/>
           </a:p>
@@ -1714,8 +1803,47 @@
         </p:nvSpPr>
         <p:spPr>
           <a:xfrm>
-            <a:off x="3996206" y="1160711"/>
-            <a:ext cx="1151439" cy="581025"/>
+            <a:off x="3438476" y="916781"/>
+            <a:ext cx="2266899" cy="1047750"/>
+          </a:xfrm>
+          <a:prstGeom prst="rect">
+            <a:avLst/>
+          </a:prstGeom>
+          <a:noFill/>
+          <a:ln/>
+        </p:spPr>
+        <p:txBody>
+          <a:bodyPr wrap="square" lIns="0" tIns="0" rIns="0" bIns="0" rtlCol="0" anchor="t"/>
+          <a:lstStyle/>
+          <a:p>
+            <a:pPr algn="ctr" indent="0" marL="0">
+              <a:buNone/>
+            </a:pPr>
+            <a:r>
+              <a:rPr lang="en-US" sz="7200" b="1" dirty="0">
+                <a:solidFill>
+                  <a:srgbClr val="F8FAFC"/>
+                </a:solidFill>
+                <a:latin typeface="Arial" pitchFamily="34" charset="0"/>
+                <a:ea typeface="Arial" pitchFamily="34" charset="-122"/>
+                <a:cs typeface="Arial" pitchFamily="34" charset="-120"/>
+              </a:rPr>
+              <a:t>ORK</a:t>
+            </a:r>
+            <a:endParaRPr lang="en-US" sz="7200" dirty="0"/>
+          </a:p>
+        </p:txBody>
+      </p:sp>
+      <p:sp>
+        <p:nvSpPr>
+          <p:cNvPr id="4" name="Text 2"/>
+          <p:cNvSpPr/>
+          <p:nvPr/>
+        </p:nvSpPr>
+        <p:spPr>
+          <a:xfrm>
+            <a:off x="1495223" y="2091482"/>
+            <a:ext cx="6153555" cy="352425"/>
           </a:xfrm>
           <a:prstGeom prst="rect">
             <a:avLst/>
@@ -1729,38 +1857,38 @@
           <a:p>
             <a:pPr algn="ctr" indent="0" marL="0">
               <a:spcBef>
-                <a:spcPts val="2680"/>
+                <a:spcPts val="1000"/>
               </a:spcBef>
               <a:spcAft>
-                <a:spcPts val="1000"/>
-              </a:spcAft>
-              <a:buNone/>
-            </a:pPr>
-            <a:r>
-              <a:rPr lang="en-US" sz="4000" b="1" dirty="0">
-                <a:solidFill>
-                  <a:srgbClr val="F8FAFC"/>
-                </a:solidFill>
-                <a:latin typeface="Arial" pitchFamily="34" charset="0"/>
-                <a:ea typeface="Arial" pitchFamily="34" charset="-122"/>
-                <a:cs typeface="Arial" pitchFamily="34" charset="-120"/>
-              </a:rPr>
-              <a:t>ORK</a:t>
-            </a:r>
-            <a:endParaRPr lang="en-US" sz="4000" dirty="0"/>
-          </a:p>
-        </p:txBody>
-      </p:sp>
-      <p:sp>
-        <p:nvSpPr>
-          <p:cNvPr id="4" name="Text 2"/>
-          <p:cNvSpPr/>
-          <p:nvPr/>
-        </p:nvSpPr>
-        <p:spPr>
-          <a:xfrm>
-            <a:off x="2410303" y="2122587"/>
-            <a:ext cx="4323246" cy="295275"/>
+                <a:spcPts val="1992"/>
+              </a:spcAft>
+              <a:buNone/>
+            </a:pPr>
+            <a:r>
+              <a:rPr lang="en-US" sz="2400" dirty="0">
+                <a:solidFill>
+                  <a:srgbClr val="38BDF8"/>
+                </a:solidFill>
+                <a:latin typeface="Consolas" pitchFamily="34" charset="0"/>
+                <a:ea typeface="Consolas" pitchFamily="34" charset="-122"/>
+                <a:cs typeface="Consolas" pitchFamily="34" charset="-120"/>
+              </a:rPr>
+              <a:t>Trust-Oriented Orchestration Runtime</a:t>
+            </a:r>
+            <a:endParaRPr lang="en-US" sz="2400" dirty="0"/>
+          </a:p>
+        </p:txBody>
+      </p:sp>
+      <p:sp>
+        <p:nvSpPr>
+          <p:cNvPr id="5" name="Text 3"/>
+          <p:cNvSpPr/>
+          <p:nvPr/>
+        </p:nvSpPr>
+        <p:spPr>
+          <a:xfrm>
+            <a:off x="2786627" y="3077766"/>
+            <a:ext cx="3570598" cy="295275"/>
           </a:xfrm>
           <a:prstGeom prst="rect">
             <a:avLst/>
@@ -1774,10 +1902,10 @@
           <a:p>
             <a:pPr algn="ctr" indent="0" marL="0">
               <a:spcBef>
+                <a:spcPts val="3000"/>
+              </a:spcBef>
+              <a:spcAft>
                 <a:spcPts val="2000"/>
-              </a:spcBef>
-              <a:spcAft>
-                <a:spcPts val="2000"/>
               </a:spcAft>
               <a:buNone/>
             </a:pPr>
@@ -1790,7 +1918,7 @@
                 <a:ea typeface="Arial" pitchFamily="34" charset="-122"/>
                 <a:cs typeface="Arial" pitchFamily="34" charset="-120"/>
               </a:rPr>
-              <a:t>Trust-Oriented Orchestration Runtime</a:t>
+              <a:t>AI proposes. Humans approve.</a:t>
             </a:r>
             <a:endParaRPr lang="en-US" sz="2000" dirty="0"/>
           </a:p>
@@ -1798,92 +1926,18 @@
       </p:sp>
       <p:sp>
         <p:nvSpPr>
-          <p:cNvPr id="5" name="Text 3"/>
-          <p:cNvSpPr/>
-          <p:nvPr/>
-        </p:nvSpPr>
-        <p:spPr>
-          <a:xfrm>
-            <a:off x="3754078" y="2874913"/>
-            <a:ext cx="1635696" cy="568821"/>
-          </a:xfrm>
-          <a:prstGeom prst="rect">
-            <a:avLst/>
-          </a:prstGeom>
-          <a:noFill/>
-          <a:ln/>
-        </p:spPr>
-        <p:txBody>
-          <a:bodyPr wrap="square" lIns="0" tIns="0" rIns="0" bIns="0" rtlCol="0" anchor="t"/>
-          <a:lstStyle/>
-          <a:p>
-            <a:pPr algn="ctr" indent="0" marL="0">
-              <a:lnSpc>
-                <a:spcPts val="2240"/>
-              </a:lnSpc>
-              <a:spcBef>
-                <a:spcPts val="1600"/>
-              </a:spcBef>
-              <a:spcAft>
-                <a:spcPts val="2000"/>
-              </a:spcAft>
-              <a:buNone/>
-            </a:pPr>
-            <a:r>
-              <a:rPr lang="en-US" sz="1600" dirty="0">
-                <a:solidFill>
-                  <a:srgbClr val="E2E8F0"/>
-                </a:solidFill>
-                <a:latin typeface="Arial" pitchFamily="34" charset="0"/>
-                <a:ea typeface="Arial" pitchFamily="34" charset="-122"/>
-                <a:cs typeface="Arial" pitchFamily="34" charset="-120"/>
-              </a:rPr>
-              <a:t>AI proposes.</a:t>
-            </a:r>
-            <a:endParaRPr lang="en-US" sz="1600" dirty="0"/>
-          </a:p>
-          <a:p>
-            <a:pPr algn="ctr" indent="0" marL="0">
-              <a:lnSpc>
-                <a:spcPts val="2240"/>
-              </a:lnSpc>
-              <a:spcBef>
-                <a:spcPts val="1600"/>
-              </a:spcBef>
-              <a:spcAft>
-                <a:spcPts val="2000"/>
-              </a:spcAft>
-              <a:buNone/>
-            </a:pPr>
-            <a:r>
-              <a:rPr lang="en-US" sz="1600" dirty="0">
-                <a:solidFill>
-                  <a:srgbClr val="E2E8F0"/>
-                </a:solidFill>
-                <a:latin typeface="Arial" pitchFamily="34" charset="0"/>
-                <a:ea typeface="Arial" pitchFamily="34" charset="-122"/>
-                <a:cs typeface="Arial" pitchFamily="34" charset="-120"/>
-              </a:rPr>
-              <a:t>Humans approve.</a:t>
-            </a:r>
-            <a:endParaRPr lang="en-US" sz="1600" dirty="0"/>
-          </a:p>
-        </p:txBody>
-      </p:sp>
-      <p:sp>
-        <p:nvSpPr>
           <p:cNvPr id="6" name="Text 4"/>
           <p:cNvSpPr/>
           <p:nvPr/>
         </p:nvSpPr>
         <p:spPr>
           <a:xfrm>
-            <a:off x="3939629" y="3697635"/>
-            <a:ext cx="1264593" cy="371475"/>
+            <a:off x="3901529" y="3880842"/>
+            <a:ext cx="1340793" cy="345877"/>
           </a:xfrm>
           <a:prstGeom prst="roundRect">
             <a:avLst>
-              <a:gd name="adj" fmla="val 20513"/>
+              <a:gd name="adj" fmla="val 73437"/>
             </a:avLst>
           </a:prstGeom>
           <a:solidFill>
@@ -1914,7 +1968,7 @@
         </p:nvSpPr>
         <p:spPr>
           <a:xfrm>
-            <a:off x="4101862" y="3792885"/>
+            <a:off x="4101862" y="3963293"/>
             <a:ext cx="940126" cy="180975"/>
           </a:xfrm>
           <a:prstGeom prst="rect">
@@ -1933,7 +1987,7 @@
             <a:r>
               <a:rPr lang="en-US" sz="1200" dirty="0">
                 <a:solidFill>
-                  <a:srgbClr val="38BDF8"/>
+                  <a:srgbClr val="F8FAFC"/>
                 </a:solidFill>
                 <a:latin typeface="Consolas" pitchFamily="34" charset="0"/>
                 <a:ea typeface="Consolas" pitchFamily="34" charset="-122"/>
@@ -2392,28 +2446,27 @@
         </p:nvSpPr>
         <p:spPr>
           <a:xfrm>
-            <a:off x="4835426" y="2358330"/>
-            <a:ext cx="3800624" cy="1563886"/>
-          </a:xfrm>
-          <a:prstGeom prst="rect">
-            <a:avLst/>
-          </a:prstGeom>
-          <a:noFill/>
-          <a:ln/>
-        </p:spPr>
-        <p:txBody>
-          <a:bodyPr wrap="square" lIns="127000" tIns="0" rIns="0" bIns="0" rtlCol="0" anchor="t"/>
-          <a:lstStyle/>
-          <a:p>
-            <a:pPr algn="l" marL="127000" indent="-127000">
+            <a:off x="5089327" y="2358330"/>
+            <a:ext cx="3617658" cy="264021"/>
+          </a:xfrm>
+          <a:prstGeom prst="rect">
+            <a:avLst/>
+          </a:prstGeom>
+          <a:noFill/>
+          <a:ln/>
+        </p:spPr>
+        <p:txBody>
+          <a:bodyPr wrap="square" lIns="0" tIns="0" rIns="0" bIns="0" rtlCol="0" anchor="t"/>
+          <a:lstStyle/>
+          <a:p>
+            <a:pPr algn="l" indent="0" marL="0">
               <a:lnSpc>
                 <a:spcPts val="2080"/>
               </a:lnSpc>
               <a:spcAft>
                 <a:spcPts val="1000"/>
               </a:spcAft>
-              <a:buSzPct val="100000"/>
-              <a:buChar char="•"/>
+              <a:buNone/>
             </a:pPr>
             <a:r>
               <a:rPr lang="en-US" sz="1600" dirty="0">
@@ -2424,20 +2477,41 @@
                 <a:ea typeface="Arial" pitchFamily="34" charset="-122"/>
                 <a:cs typeface="Arial" pitchFamily="34" charset="-120"/>
               </a:rPr>
-              <a:t>Technical Testers</a:t>
+              <a:t>• Technical Testers</a:t>
             </a:r>
             <a:endParaRPr lang="en-US" sz="1600" dirty="0"/>
           </a:p>
-          <a:p>
-            <a:pPr algn="l" marL="127000" indent="-127000">
+        </p:txBody>
+      </p:sp>
+      <p:sp>
+        <p:nvSpPr>
+          <p:cNvPr id="13" name="Text 11"/>
+          <p:cNvSpPr/>
+          <p:nvPr/>
+        </p:nvSpPr>
+        <p:spPr>
+          <a:xfrm>
+            <a:off x="5089327" y="2749302"/>
+            <a:ext cx="3617658" cy="264021"/>
+          </a:xfrm>
+          <a:prstGeom prst="rect">
+            <a:avLst/>
+          </a:prstGeom>
+          <a:noFill/>
+          <a:ln/>
+        </p:spPr>
+        <p:txBody>
+          <a:bodyPr wrap="square" lIns="0" tIns="0" rIns="0" bIns="0" rtlCol="0" anchor="t"/>
+          <a:lstStyle/>
+          <a:p>
+            <a:pPr algn="l" indent="0" marL="0">
               <a:lnSpc>
                 <a:spcPts val="2080"/>
               </a:lnSpc>
               <a:spcAft>
                 <a:spcPts val="1000"/>
               </a:spcAft>
-              <a:buSzPct val="100000"/>
-              <a:buChar char="•"/>
+              <a:buNone/>
             </a:pPr>
             <a:r>
               <a:rPr lang="en-US" sz="1600" dirty="0">
@@ -2448,20 +2522,41 @@
                 <a:ea typeface="Arial" pitchFamily="34" charset="-122"/>
                 <a:cs typeface="Arial" pitchFamily="34" charset="-120"/>
               </a:rPr>
-              <a:t>Bug Reports</a:t>
+              <a:t>• Bug Reports</a:t>
             </a:r>
             <a:endParaRPr lang="en-US" sz="1600" dirty="0"/>
           </a:p>
-          <a:p>
-            <a:pPr algn="l" marL="127000" indent="-127000">
+        </p:txBody>
+      </p:sp>
+      <p:sp>
+        <p:nvSpPr>
+          <p:cNvPr id="14" name="Text 12"/>
+          <p:cNvSpPr/>
+          <p:nvPr/>
+        </p:nvSpPr>
+        <p:spPr>
+          <a:xfrm>
+            <a:off x="5089327" y="3140273"/>
+            <a:ext cx="3617658" cy="264021"/>
+          </a:xfrm>
+          <a:prstGeom prst="rect">
+            <a:avLst/>
+          </a:prstGeom>
+          <a:noFill/>
+          <a:ln/>
+        </p:spPr>
+        <p:txBody>
+          <a:bodyPr wrap="square" lIns="0" tIns="0" rIns="0" bIns="0" rtlCol="0" anchor="t"/>
+          <a:lstStyle/>
+          <a:p>
+            <a:pPr algn="l" indent="0" marL="0">
               <a:lnSpc>
                 <a:spcPts val="2080"/>
               </a:lnSpc>
               <a:spcAft>
                 <a:spcPts val="1000"/>
               </a:spcAft>
-              <a:buSzPct val="100000"/>
-              <a:buChar char="•"/>
+              <a:buNone/>
             </a:pPr>
             <a:r>
               <a:rPr lang="en-US" sz="1600" dirty="0">
@@ -2472,20 +2567,41 @@
                 <a:ea typeface="Arial" pitchFamily="34" charset="-122"/>
                 <a:cs typeface="Arial" pitchFamily="34" charset="-120"/>
               </a:rPr>
-              <a:t>Reliability Feedback</a:t>
+              <a:t>• Reliability Feedback</a:t>
             </a:r>
             <a:endParaRPr lang="en-US" sz="1600" dirty="0"/>
           </a:p>
-          <a:p>
-            <a:pPr algn="l" marL="127000" indent="-127000">
+        </p:txBody>
+      </p:sp>
+      <p:sp>
+        <p:nvSpPr>
+          <p:cNvPr id="15" name="Text 13"/>
+          <p:cNvSpPr/>
+          <p:nvPr/>
+        </p:nvSpPr>
+        <p:spPr>
+          <a:xfrm>
+            <a:off x="5089327" y="3531245"/>
+            <a:ext cx="3617658" cy="264021"/>
+          </a:xfrm>
+          <a:prstGeom prst="rect">
+            <a:avLst/>
+          </a:prstGeom>
+          <a:noFill/>
+          <a:ln/>
+        </p:spPr>
+        <p:txBody>
+          <a:bodyPr wrap="square" lIns="0" tIns="0" rIns="0" bIns="0" rtlCol="0" anchor="t"/>
+          <a:lstStyle/>
+          <a:p>
+            <a:pPr algn="l" indent="0" marL="0">
               <a:lnSpc>
                 <a:spcPts val="2080"/>
               </a:lnSpc>
               <a:spcAft>
                 <a:spcPts val="1000"/>
               </a:spcAft>
-              <a:buSzPct val="100000"/>
-              <a:buChar char="•"/>
+              <a:buNone/>
             </a:pPr>
             <a:r>
               <a:rPr lang="en-US" sz="1600" dirty="0">
@@ -2496,9 +2612,371 @@
                 <a:ea typeface="Arial" pitchFamily="34" charset="-122"/>
                 <a:cs typeface="Arial" pitchFamily="34" charset="-120"/>
               </a:rPr>
-              <a:t>Open-Source Contributors</a:t>
+              <a:t>• Open-Source Contributors</a:t>
             </a:r>
             <a:endParaRPr lang="en-US" sz="1600" dirty="0"/>
+          </a:p>
+        </p:txBody>
+      </p:sp>
+    </p:spTree>
+  </p:cSld>
+  <p:clrMapOvr>
+    <a:masterClrMapping/>
+  </p:clrMapOvr>
+</p:sld>
+</file>
+
+<file path=ppt/slides/slide11.xml><?xml version="1.0" encoding="utf-8"?>
+<p:sld xmlns:a="http://schemas.openxmlformats.org/drawingml/2006/main" xmlns:r="http://schemas.openxmlformats.org/officeDocument/2006/relationships" xmlns:p="http://schemas.openxmlformats.org/presentationml/2006/main">
+  <p:cSld name="Slide 11">
+    <p:bg>
+      <p:bgPr>
+        <a:solidFill>
+          <a:srgbClr val="0F172A"/>
+        </a:solidFill>
+      </p:bgPr>
+    </p:bg>
+    <p:spTree>
+      <p:nvGrpSpPr>
+        <p:cNvPr id="1" name=""/>
+        <p:cNvGrpSpPr/>
+        <p:nvPr/>
+      </p:nvGrpSpPr>
+      <p:grpSpPr>
+        <a:xfrm>
+          <a:off x="0" y="0"/>
+          <a:ext cx="0" cy="0"/>
+          <a:chOff x="0" y="0"/>
+          <a:chExt cx="0" cy="0"/>
+        </a:xfrm>
+      </p:grpSpPr>
+      <p:sp>
+        <p:nvSpPr>
+          <p:cNvPr id="2" name="Text 0"/>
+          <p:cNvSpPr/>
+          <p:nvPr/>
+        </p:nvSpPr>
+        <p:spPr>
+          <a:xfrm>
+            <a:off x="0" y="0"/>
+            <a:ext cx="9144000" cy="5143500"/>
+          </a:xfrm>
+          <a:prstGeom prst="rect">
+            <a:avLst/>
+          </a:prstGeom>
+          <a:solidFill>
+            <a:srgbClr val="0F172A"/>
+          </a:solidFill>
+          <a:ln/>
+        </p:spPr>
+        <p:txBody>
+          <a:bodyPr wrap="square" rtlCol="0" anchor="ctr"/>
+          <a:lstStyle/>
+          <a:p>
+            <a:pPr indent="0" marL="0">
+              <a:buNone/>
+            </a:pPr>
+            <a:endParaRPr lang="en-US" dirty="0"/>
+          </a:p>
+        </p:txBody>
+      </p:sp>
+      <p:sp>
+        <p:nvSpPr>
+          <p:cNvPr id="3" name="Text 1"/>
+          <p:cNvSpPr/>
+          <p:nvPr/>
+        </p:nvSpPr>
+        <p:spPr>
+          <a:xfrm>
+            <a:off x="2491517" y="455265"/>
+            <a:ext cx="4160966" cy="933450"/>
+          </a:xfrm>
+          <a:prstGeom prst="rect">
+            <a:avLst/>
+          </a:prstGeom>
+          <a:noFill/>
+          <a:ln/>
+        </p:spPr>
+        <p:txBody>
+          <a:bodyPr wrap="square" lIns="0" tIns="0" rIns="0" bIns="0" rtlCol="0" anchor="t"/>
+          <a:lstStyle/>
+          <a:p>
+            <a:pPr algn="ctr" indent="0" marL="0">
+              <a:spcAft>
+                <a:spcPts val="2000"/>
+              </a:spcAft>
+              <a:buNone/>
+            </a:pPr>
+            <a:r>
+              <a:rPr lang="en-US" sz="6400" b="1" dirty="0">
+                <a:solidFill>
+                  <a:srgbClr val="F8FAFC"/>
+                </a:solidFill>
+                <a:latin typeface="Arial" pitchFamily="34" charset="0"/>
+                <a:ea typeface="Arial" pitchFamily="34" charset="-122"/>
+                <a:cs typeface="Arial" pitchFamily="34" charset="-120"/>
+              </a:rPr>
+              <a:t>Thank You</a:t>
+            </a:r>
+            <a:endParaRPr lang="en-US" sz="6400" dirty="0"/>
+          </a:p>
+        </p:txBody>
+      </p:sp>
+      <p:sp>
+        <p:nvSpPr>
+          <p:cNvPr id="4" name="Text 2"/>
+          <p:cNvSpPr/>
+          <p:nvPr/>
+        </p:nvSpPr>
+        <p:spPr>
+          <a:xfrm>
+            <a:off x="3438476" y="1642616"/>
+            <a:ext cx="2266899" cy="1047750"/>
+          </a:xfrm>
+          <a:prstGeom prst="rect">
+            <a:avLst/>
+          </a:prstGeom>
+          <a:noFill/>
+          <a:ln/>
+        </p:spPr>
+        <p:txBody>
+          <a:bodyPr wrap="square" lIns="0" tIns="0" rIns="0" bIns="0" rtlCol="0" anchor="t"/>
+          <a:lstStyle/>
+          <a:p>
+            <a:pPr algn="ctr" indent="0" marL="0">
+              <a:buNone/>
+            </a:pPr>
+            <a:r>
+              <a:rPr lang="en-US" sz="7200" b="1" dirty="0">
+                <a:solidFill>
+                  <a:srgbClr val="F8FAFC"/>
+                </a:solidFill>
+                <a:latin typeface="Arial" pitchFamily="34" charset="0"/>
+                <a:ea typeface="Arial" pitchFamily="34" charset="-122"/>
+                <a:cs typeface="Arial" pitchFamily="34" charset="-120"/>
+              </a:rPr>
+              <a:t>ORK</a:t>
+            </a:r>
+            <a:endParaRPr lang="en-US" sz="7200" dirty="0"/>
+          </a:p>
+        </p:txBody>
+      </p:sp>
+      <p:sp>
+        <p:nvSpPr>
+          <p:cNvPr id="5" name="Text 3"/>
+          <p:cNvSpPr/>
+          <p:nvPr/>
+        </p:nvSpPr>
+        <p:spPr>
+          <a:xfrm>
+            <a:off x="2008626" y="2817316"/>
+            <a:ext cx="5126748" cy="304800"/>
+          </a:xfrm>
+          <a:prstGeom prst="rect">
+            <a:avLst/>
+          </a:prstGeom>
+          <a:noFill/>
+          <a:ln/>
+        </p:spPr>
+        <p:txBody>
+          <a:bodyPr wrap="square" lIns="0" tIns="0" rIns="0" bIns="0" rtlCol="0" anchor="t"/>
+          <a:lstStyle/>
+          <a:p>
+            <a:pPr algn="ctr" indent="0" marL="0">
+              <a:spcBef>
+                <a:spcPts val="1000"/>
+              </a:spcBef>
+              <a:spcAft>
+                <a:spcPts val="1660"/>
+              </a:spcAft>
+              <a:buNone/>
+            </a:pPr>
+            <a:r>
+              <a:rPr lang="en-US" sz="2000" dirty="0">
+                <a:solidFill>
+                  <a:srgbClr val="38BDF8"/>
+                </a:solidFill>
+                <a:latin typeface="Consolas" pitchFamily="34" charset="0"/>
+                <a:ea typeface="Consolas" pitchFamily="34" charset="-122"/>
+                <a:cs typeface="Consolas" pitchFamily="34" charset="-120"/>
+              </a:rPr>
+              <a:t>Trust-Oriented Orchestration Runtime</a:t>
+            </a:r>
+            <a:endParaRPr lang="en-US" sz="2000" dirty="0"/>
+          </a:p>
+        </p:txBody>
+      </p:sp>
+      <p:sp>
+        <p:nvSpPr>
+          <p:cNvPr id="6" name="Text 4"/>
+          <p:cNvSpPr/>
+          <p:nvPr/>
+        </p:nvSpPr>
+        <p:spPr>
+          <a:xfrm>
+            <a:off x="3143519" y="3523357"/>
+            <a:ext cx="2856812" cy="238125"/>
+          </a:xfrm>
+          <a:prstGeom prst="rect">
+            <a:avLst/>
+          </a:prstGeom>
+          <a:noFill/>
+          <a:ln/>
+        </p:spPr>
+        <p:txBody>
+          <a:bodyPr wrap="square" lIns="0" tIns="0" rIns="0" bIns="0" rtlCol="0" anchor="t"/>
+          <a:lstStyle/>
+          <a:p>
+            <a:pPr algn="ctr" indent="0" marL="0">
+              <a:spcBef>
+                <a:spcPts val="1500"/>
+              </a:spcBef>
+              <a:spcAft>
+                <a:spcPts val="2000"/>
+              </a:spcAft>
+              <a:buNone/>
+            </a:pPr>
+            <a:r>
+              <a:rPr lang="en-US" sz="1600" dirty="0">
+                <a:solidFill>
+                  <a:srgbClr val="94A3B8"/>
+                </a:solidFill>
+                <a:latin typeface="Arial" pitchFamily="34" charset="0"/>
+                <a:ea typeface="Arial" pitchFamily="34" charset="-122"/>
+                <a:cs typeface="Arial" pitchFamily="34" charset="-120"/>
+              </a:rPr>
+              <a:t>AI proposes. Humans approve.</a:t>
+            </a:r>
+            <a:endParaRPr lang="en-US" sz="1600" dirty="0"/>
+          </a:p>
+        </p:txBody>
+      </p:sp>
+      <p:sp>
+        <p:nvSpPr>
+          <p:cNvPr id="7" name="Text 5"/>
+          <p:cNvSpPr/>
+          <p:nvPr/>
+        </p:nvSpPr>
+        <p:spPr>
+          <a:xfrm>
+            <a:off x="2528559" y="4078784"/>
+            <a:ext cx="4086734" cy="209550"/>
+          </a:xfrm>
+          <a:prstGeom prst="rect">
+            <a:avLst/>
+          </a:prstGeom>
+          <a:noFill/>
+          <a:ln/>
+        </p:spPr>
+        <p:txBody>
+          <a:bodyPr wrap="square" lIns="0" tIns="0" rIns="0" bIns="0" rtlCol="0" anchor="t"/>
+          <a:lstStyle/>
+          <a:p>
+            <a:pPr algn="ctr" indent="0" marL="0">
+              <a:spcBef>
+                <a:spcPts val="500"/>
+              </a:spcBef>
+              <a:spcAft>
+                <a:spcPts val="500"/>
+              </a:spcAft>
+              <a:buNone/>
+            </a:pPr>
+            <a:r>
+              <a:rPr lang="en-US" sz="1400" dirty="0">
+                <a:solidFill>
+                  <a:srgbClr val="F8FAFC"/>
+                </a:solidFill>
+                <a:latin typeface="Consolas" pitchFamily="34" charset="0"/>
+                <a:ea typeface="Consolas" pitchFamily="34" charset="-122"/>
+                <a:cs typeface="Consolas" pitchFamily="34" charset="-120"/>
+              </a:rPr>
+              <a:t>GitHub: https://github.com/v7-vdev/ai-cli</a:t>
+            </a:r>
+            <a:endParaRPr lang="en-US" sz="1400" dirty="0"/>
+          </a:p>
+        </p:txBody>
+      </p:sp>
+      <p:sp>
+        <p:nvSpPr>
+          <p:cNvPr id="8" name="Text 6"/>
+          <p:cNvSpPr/>
+          <p:nvPr/>
+        </p:nvSpPr>
+        <p:spPr>
+          <a:xfrm>
+            <a:off x="2678086" y="4415135"/>
+            <a:ext cx="3787679" cy="209550"/>
+          </a:xfrm>
+          <a:prstGeom prst="rect">
+            <a:avLst/>
+          </a:prstGeom>
+          <a:noFill/>
+          <a:ln/>
+        </p:spPr>
+        <p:txBody>
+          <a:bodyPr wrap="square" lIns="0" tIns="0" rIns="0" bIns="0" rtlCol="0" anchor="t"/>
+          <a:lstStyle/>
+          <a:p>
+            <a:pPr algn="ctr" indent="0" marL="0">
+              <a:spcBef>
+                <a:spcPts val="500"/>
+              </a:spcBef>
+              <a:spcAft>
+                <a:spcPts val="500"/>
+              </a:spcAft>
+              <a:buNone/>
+            </a:pPr>
+            <a:r>
+              <a:rPr lang="en-US" sz="1400" dirty="0">
+                <a:solidFill>
+                  <a:srgbClr val="F8FAFC"/>
+                </a:solidFill>
+                <a:latin typeface="Consolas" pitchFamily="34" charset="0"/>
+                <a:ea typeface="Consolas" pitchFamily="34" charset="-122"/>
+                <a:cs typeface="Consolas" pitchFamily="34" charset="-120"/>
+              </a:rPr>
+              <a:t>Discord: https://discord.gg/mJWFajpfgk</a:t>
+            </a:r>
+            <a:endParaRPr lang="en-US" sz="1400" dirty="0"/>
+          </a:p>
+        </p:txBody>
+      </p:sp>
+      <p:sp>
+        <p:nvSpPr>
+          <p:cNvPr id="9" name="Text 7"/>
+          <p:cNvSpPr/>
+          <p:nvPr/>
+        </p:nvSpPr>
+        <p:spPr>
+          <a:xfrm>
+            <a:off x="-91440" y="4708624"/>
+            <a:ext cx="9326880" cy="180975"/>
+          </a:xfrm>
+          <a:prstGeom prst="rect">
+            <a:avLst/>
+          </a:prstGeom>
+          <a:noFill/>
+          <a:ln/>
+        </p:spPr>
+        <p:txBody>
+          <a:bodyPr wrap="square" lIns="0" tIns="0" rIns="0" bIns="0" rtlCol="0" anchor="t"/>
+          <a:lstStyle/>
+          <a:p>
+            <a:pPr algn="ctr" indent="0" marL="0">
+              <a:buNone/>
+            </a:pPr>
+            <a:r>
+              <a:rPr lang="en-US" sz="1200" dirty="0">
+                <a:solidFill>
+                  <a:srgbClr val="475569"/>
+                </a:solidFill>
+                <a:latin typeface="Consolas" pitchFamily="34" charset="0"/>
+                <a:ea typeface="Consolas" pitchFamily="34" charset="-122"/>
+                <a:cs typeface="Consolas" pitchFamily="34" charset="-120"/>
+              </a:rPr>
+              <a:t>Public Technical Validation</a:t>
+            </a:r>
+            <a:endParaRPr lang="en-US" sz="1200" dirty="0"/>
           </a:p>
         </p:txBody>
       </p:sp>
@@ -2663,11 +3141,11 @@
         <p:spPr>
           <a:xfrm>
             <a:off x="507950" y="1907530"/>
-            <a:ext cx="3937099" cy="2732038"/>
+            <a:ext cx="3937099" cy="2664470"/>
           </a:xfrm>
           <a:prstGeom prst="roundRect">
             <a:avLst>
-              <a:gd name="adj" fmla="val 3719"/>
+              <a:gd name="adj" fmla="val 3813"/>
             </a:avLst>
           </a:prstGeom>
           <a:solidFill>
@@ -2743,28 +3221,27 @@
         </p:nvSpPr>
         <p:spPr>
           <a:xfrm>
-            <a:off x="717500" y="2802731"/>
-            <a:ext cx="3517999" cy="1563886"/>
-          </a:xfrm>
-          <a:prstGeom prst="rect">
-            <a:avLst/>
-          </a:prstGeom>
-          <a:noFill/>
-          <a:ln/>
-        </p:spPr>
-        <p:txBody>
-          <a:bodyPr wrap="square" lIns="127000" tIns="0" rIns="0" bIns="0" rtlCol="0" anchor="t"/>
-          <a:lstStyle/>
-          <a:p>
-            <a:pPr algn="l" marL="127000" indent="-127000">
+            <a:off x="971401" y="2739330"/>
+            <a:ext cx="3329380" cy="264021"/>
+          </a:xfrm>
+          <a:prstGeom prst="rect">
+            <a:avLst/>
+          </a:prstGeom>
+          <a:noFill/>
+          <a:ln/>
+        </p:spPr>
+        <p:txBody>
+          <a:bodyPr wrap="square" lIns="0" tIns="0" rIns="0" bIns="0" rtlCol="0" anchor="t"/>
+          <a:lstStyle/>
+          <a:p>
+            <a:pPr algn="l" indent="0" marL="0">
               <a:lnSpc>
                 <a:spcPts val="2080"/>
               </a:lnSpc>
               <a:spcAft>
                 <a:spcPts val="1000"/>
               </a:spcAft>
-              <a:buSzPct val="100000"/>
-              <a:buChar char="•"/>
+              <a:buNone/>
             </a:pPr>
             <a:r>
               <a:rPr lang="en-US" sz="1600" dirty="0">
@@ -2775,20 +3252,41 @@
                 <a:ea typeface="Arial" pitchFamily="34" charset="-122"/>
                 <a:cs typeface="Arial" pitchFamily="34" charset="-120"/>
               </a:rPr>
-              <a:t>Hidden execution paths</a:t>
+              <a:t>• Hidden execution paths</a:t>
             </a:r>
             <a:endParaRPr lang="en-US" sz="1600" dirty="0"/>
           </a:p>
-          <a:p>
-            <a:pPr algn="l" marL="127000" indent="-127000">
+        </p:txBody>
+      </p:sp>
+      <p:sp>
+        <p:nvSpPr>
+          <p:cNvPr id="8" name="Text 6"/>
+          <p:cNvSpPr/>
+          <p:nvPr/>
+        </p:nvSpPr>
+        <p:spPr>
+          <a:xfrm>
+            <a:off x="971401" y="3130302"/>
+            <a:ext cx="3329380" cy="264021"/>
+          </a:xfrm>
+          <a:prstGeom prst="rect">
+            <a:avLst/>
+          </a:prstGeom>
+          <a:noFill/>
+          <a:ln/>
+        </p:spPr>
+        <p:txBody>
+          <a:bodyPr wrap="square" lIns="0" tIns="0" rIns="0" bIns="0" rtlCol="0" anchor="t"/>
+          <a:lstStyle/>
+          <a:p>
+            <a:pPr algn="l" indent="0" marL="0">
               <a:lnSpc>
                 <a:spcPts val="2080"/>
               </a:lnSpc>
               <a:spcAft>
                 <a:spcPts val="1000"/>
               </a:spcAft>
-              <a:buSzPct val="100000"/>
-              <a:buChar char="•"/>
+              <a:buNone/>
             </a:pPr>
             <a:r>
               <a:rPr lang="en-US" sz="1600" dirty="0">
@@ -2799,20 +3297,41 @@
                 <a:ea typeface="Arial" pitchFamily="34" charset="-122"/>
                 <a:cs typeface="Arial" pitchFamily="34" charset="-120"/>
               </a:rPr>
-              <a:t>Excessive autonomy</a:t>
+              <a:t>• Excessive autonomy</a:t>
             </a:r>
             <a:endParaRPr lang="en-US" sz="1600" dirty="0"/>
           </a:p>
-          <a:p>
-            <a:pPr algn="l" marL="127000" indent="-127000">
+        </p:txBody>
+      </p:sp>
+      <p:sp>
+        <p:nvSpPr>
+          <p:cNvPr id="9" name="Text 7"/>
+          <p:cNvSpPr/>
+          <p:nvPr/>
+        </p:nvSpPr>
+        <p:spPr>
+          <a:xfrm>
+            <a:off x="971401" y="3521273"/>
+            <a:ext cx="3329380" cy="264021"/>
+          </a:xfrm>
+          <a:prstGeom prst="rect">
+            <a:avLst/>
+          </a:prstGeom>
+          <a:noFill/>
+          <a:ln/>
+        </p:spPr>
+        <p:txBody>
+          <a:bodyPr wrap="square" lIns="0" tIns="0" rIns="0" bIns="0" rtlCol="0" anchor="t"/>
+          <a:lstStyle/>
+          <a:p>
+            <a:pPr algn="l" indent="0" marL="0">
               <a:lnSpc>
                 <a:spcPts val="2080"/>
               </a:lnSpc>
               <a:spcAft>
                 <a:spcPts val="1000"/>
               </a:spcAft>
-              <a:buSzPct val="100000"/>
-              <a:buChar char="•"/>
+              <a:buNone/>
             </a:pPr>
             <a:r>
               <a:rPr lang="en-US" sz="1600" dirty="0">
@@ -2823,20 +3342,41 @@
                 <a:ea typeface="Arial" pitchFamily="34" charset="-122"/>
                 <a:cs typeface="Arial" pitchFamily="34" charset="-120"/>
               </a:rPr>
-              <a:t>Difficult debugging</a:t>
+              <a:t>• Difficult debugging</a:t>
             </a:r>
             <a:endParaRPr lang="en-US" sz="1600" dirty="0"/>
           </a:p>
-          <a:p>
-            <a:pPr algn="l" marL="127000" indent="-127000">
+        </p:txBody>
+      </p:sp>
+      <p:sp>
+        <p:nvSpPr>
+          <p:cNvPr id="10" name="Text 8"/>
+          <p:cNvSpPr/>
+          <p:nvPr/>
+        </p:nvSpPr>
+        <p:spPr>
+          <a:xfrm>
+            <a:off x="971401" y="3912245"/>
+            <a:ext cx="3329380" cy="264021"/>
+          </a:xfrm>
+          <a:prstGeom prst="rect">
+            <a:avLst/>
+          </a:prstGeom>
+          <a:noFill/>
+          <a:ln/>
+        </p:spPr>
+        <p:txBody>
+          <a:bodyPr wrap="square" lIns="0" tIns="0" rIns="0" bIns="0" rtlCol="0" anchor="t"/>
+          <a:lstStyle/>
+          <a:p>
+            <a:pPr algn="l" indent="0" marL="0">
               <a:lnSpc>
                 <a:spcPts val="2080"/>
               </a:lnSpc>
               <a:spcAft>
                 <a:spcPts val="1000"/>
               </a:spcAft>
-              <a:buSzPct val="100000"/>
-              <a:buChar char="•"/>
+              <a:buNone/>
             </a:pPr>
             <a:r>
               <a:rPr lang="en-US" sz="1600" dirty="0">
@@ -2847,7 +3387,7 @@
                 <a:ea typeface="Arial" pitchFamily="34" charset="-122"/>
                 <a:cs typeface="Arial" pitchFamily="34" charset="-120"/>
               </a:rPr>
-              <a:t>Reduced operator control</a:t>
+              <a:t>• Reduced operator control</a:t>
             </a:r>
             <a:endParaRPr lang="en-US" sz="1600" dirty="0"/>
           </a:p>
@@ -2855,18 +3395,18 @@
       </p:sp>
       <p:sp>
         <p:nvSpPr>
-          <p:cNvPr id="8" name="Text 6"/>
+          <p:cNvPr id="11" name="Text 9"/>
           <p:cNvSpPr/>
           <p:nvPr/>
         </p:nvSpPr>
         <p:spPr>
           <a:xfrm>
             <a:off x="4698950" y="1907530"/>
-            <a:ext cx="3937099" cy="2732038"/>
+            <a:ext cx="3937099" cy="2664470"/>
           </a:xfrm>
           <a:prstGeom prst="roundRect">
             <a:avLst>
-              <a:gd name="adj" fmla="val 3719"/>
+              <a:gd name="adj" fmla="val 3813"/>
             </a:avLst>
           </a:prstGeom>
           <a:solidFill>
@@ -2891,7 +3431,7 @@
       </p:sp>
       <p:sp>
         <p:nvSpPr>
-          <p:cNvPr id="9" name="Text 7"/>
+          <p:cNvPr id="12" name="Text 10"/>
           <p:cNvSpPr/>
           <p:nvPr/>
         </p:nvSpPr>
@@ -2936,34 +3476,33 @@
       </p:sp>
       <p:sp>
         <p:nvSpPr>
-          <p:cNvPr id="10" name="Text 8"/>
-          <p:cNvSpPr/>
-          <p:nvPr/>
-        </p:nvSpPr>
-        <p:spPr>
-          <a:xfrm>
-            <a:off x="4908500" y="2802731"/>
-            <a:ext cx="3517999" cy="1563886"/>
-          </a:xfrm>
-          <a:prstGeom prst="rect">
-            <a:avLst/>
-          </a:prstGeom>
-          <a:noFill/>
-          <a:ln/>
-        </p:spPr>
-        <p:txBody>
-          <a:bodyPr wrap="square" lIns="127000" tIns="0" rIns="0" bIns="0" rtlCol="0" anchor="t"/>
-          <a:lstStyle/>
-          <a:p>
-            <a:pPr algn="l" marL="127000" indent="-127000">
+          <p:cNvPr id="13" name="Text 11"/>
+          <p:cNvSpPr/>
+          <p:nvPr/>
+        </p:nvSpPr>
+        <p:spPr>
+          <a:xfrm>
+            <a:off x="5162401" y="2739330"/>
+            <a:ext cx="3329380" cy="264021"/>
+          </a:xfrm>
+          <a:prstGeom prst="rect">
+            <a:avLst/>
+          </a:prstGeom>
+          <a:noFill/>
+          <a:ln/>
+        </p:spPr>
+        <p:txBody>
+          <a:bodyPr wrap="square" lIns="0" tIns="0" rIns="0" bIns="0" rtlCol="0" anchor="t"/>
+          <a:lstStyle/>
+          <a:p>
+            <a:pPr algn="l" indent="0" marL="0">
               <a:lnSpc>
                 <a:spcPts val="2080"/>
               </a:lnSpc>
               <a:spcAft>
                 <a:spcPts val="1000"/>
               </a:spcAft>
-              <a:buSzPct val="100000"/>
-              <a:buChar char="•"/>
+              <a:buNone/>
             </a:pPr>
             <a:r>
               <a:rPr lang="en-US" sz="1600" dirty="0">
@@ -2974,20 +3513,41 @@
                 <a:ea typeface="Arial" pitchFamily="34" charset="-122"/>
                 <a:cs typeface="Arial" pitchFamily="34" charset="-120"/>
               </a:rPr>
-              <a:t>Explicit approval</a:t>
+              <a:t>• Explicit approval</a:t>
             </a:r>
             <a:endParaRPr lang="en-US" sz="1600" dirty="0"/>
           </a:p>
-          <a:p>
-            <a:pPr algn="l" marL="127000" indent="-127000">
+        </p:txBody>
+      </p:sp>
+      <p:sp>
+        <p:nvSpPr>
+          <p:cNvPr id="14" name="Text 12"/>
+          <p:cNvSpPr/>
+          <p:nvPr/>
+        </p:nvSpPr>
+        <p:spPr>
+          <a:xfrm>
+            <a:off x="5162401" y="3130302"/>
+            <a:ext cx="3329380" cy="264021"/>
+          </a:xfrm>
+          <a:prstGeom prst="rect">
+            <a:avLst/>
+          </a:prstGeom>
+          <a:noFill/>
+          <a:ln/>
+        </p:spPr>
+        <p:txBody>
+          <a:bodyPr wrap="square" lIns="0" tIns="0" rIns="0" bIns="0" rtlCol="0" anchor="t"/>
+          <a:lstStyle/>
+          <a:p>
+            <a:pPr algn="l" indent="0" marL="0">
               <a:lnSpc>
                 <a:spcPts val="2080"/>
               </a:lnSpc>
               <a:spcAft>
                 <a:spcPts val="1000"/>
               </a:spcAft>
-              <a:buSzPct val="100000"/>
-              <a:buChar char="•"/>
+              <a:buNone/>
             </a:pPr>
             <a:r>
               <a:rPr lang="en-US" sz="1600" dirty="0">
@@ -2998,20 +3558,41 @@
                 <a:ea typeface="Arial" pitchFamily="34" charset="-122"/>
                 <a:cs typeface="Arial" pitchFamily="34" charset="-120"/>
               </a:rPr>
-              <a:t>Deterministic behavior</a:t>
+              <a:t>• Deterministic behavior</a:t>
             </a:r>
             <a:endParaRPr lang="en-US" sz="1600" dirty="0"/>
           </a:p>
-          <a:p>
-            <a:pPr algn="l" marL="127000" indent="-127000">
+        </p:txBody>
+      </p:sp>
+      <p:sp>
+        <p:nvSpPr>
+          <p:cNvPr id="15" name="Text 13"/>
+          <p:cNvSpPr/>
+          <p:nvPr/>
+        </p:nvSpPr>
+        <p:spPr>
+          <a:xfrm>
+            <a:off x="5162401" y="3521273"/>
+            <a:ext cx="3329380" cy="264021"/>
+          </a:xfrm>
+          <a:prstGeom prst="rect">
+            <a:avLst/>
+          </a:prstGeom>
+          <a:noFill/>
+          <a:ln/>
+        </p:spPr>
+        <p:txBody>
+          <a:bodyPr wrap="square" lIns="0" tIns="0" rIns="0" bIns="0" rtlCol="0" anchor="t"/>
+          <a:lstStyle/>
+          <a:p>
+            <a:pPr algn="l" indent="0" marL="0">
               <a:lnSpc>
                 <a:spcPts val="2080"/>
               </a:lnSpc>
               <a:spcAft>
                 <a:spcPts val="1000"/>
               </a:spcAft>
-              <a:buSzPct val="100000"/>
-              <a:buChar char="•"/>
+              <a:buNone/>
             </a:pPr>
             <a:r>
               <a:rPr lang="en-US" sz="1600" dirty="0">
@@ -3022,20 +3603,41 @@
                 <a:ea typeface="Arial" pitchFamily="34" charset="-122"/>
                 <a:cs typeface="Arial" pitchFamily="34" charset="-120"/>
               </a:rPr>
-              <a:t>Clear execution visibility</a:t>
+              <a:t>• Clear execution visibility</a:t>
             </a:r>
             <a:endParaRPr lang="en-US" sz="1600" dirty="0"/>
           </a:p>
-          <a:p>
-            <a:pPr algn="l" marL="127000" indent="-127000">
+        </p:txBody>
+      </p:sp>
+      <p:sp>
+        <p:nvSpPr>
+          <p:cNvPr id="16" name="Text 14"/>
+          <p:cNvSpPr/>
+          <p:nvPr/>
+        </p:nvSpPr>
+        <p:spPr>
+          <a:xfrm>
+            <a:off x="5162401" y="3912245"/>
+            <a:ext cx="3329380" cy="264021"/>
+          </a:xfrm>
+          <a:prstGeom prst="rect">
+            <a:avLst/>
+          </a:prstGeom>
+          <a:noFill/>
+          <a:ln/>
+        </p:spPr>
+        <p:txBody>
+          <a:bodyPr wrap="square" lIns="0" tIns="0" rIns="0" bIns="0" rtlCol="0" anchor="t"/>
+          <a:lstStyle/>
+          <a:p>
+            <a:pPr algn="l" indent="0" marL="0">
               <a:lnSpc>
                 <a:spcPts val="2080"/>
               </a:lnSpc>
               <a:spcAft>
                 <a:spcPts val="1000"/>
               </a:spcAft>
-              <a:buSzPct val="100000"/>
-              <a:buChar char="•"/>
+              <a:buNone/>
             </a:pPr>
             <a:r>
               <a:rPr lang="en-US" sz="1600" dirty="0">
@@ -3046,7 +3648,7 @@
                 <a:ea typeface="Arial" pitchFamily="34" charset="-122"/>
                 <a:cs typeface="Arial" pitchFamily="34" charset="-120"/>
               </a:rPr>
-              <a:t>Hard trust boundaries</a:t>
+              <a:t>• Hard trust boundaries</a:t>
             </a:r>
             <a:endParaRPr lang="en-US" sz="1600" dirty="0"/>
           </a:p>
@@ -3248,31 +3850,30 @@
         </p:nvSpPr>
         <p:spPr>
           <a:xfrm>
-            <a:off x="717500" y="2307431"/>
-            <a:ext cx="7708999" cy="1954857"/>
-          </a:xfrm>
-          <a:prstGeom prst="rect">
-            <a:avLst/>
-          </a:prstGeom>
-          <a:noFill/>
-          <a:ln/>
-        </p:spPr>
-        <p:txBody>
-          <a:bodyPr wrap="square" lIns="127000" tIns="0" rIns="0" bIns="0" rtlCol="0" anchor="t"/>
-          <a:lstStyle/>
-          <a:p>
-            <a:pPr algn="l" marL="127000" indent="-127000">
+            <a:off x="971401" y="2244030"/>
+            <a:ext cx="7604200" cy="264021"/>
+          </a:xfrm>
+          <a:prstGeom prst="rect">
+            <a:avLst/>
+          </a:prstGeom>
+          <a:noFill/>
+          <a:ln/>
+        </p:spPr>
+        <p:txBody>
+          <a:bodyPr wrap="square" lIns="0" tIns="0" rIns="0" bIns="0" rtlCol="0" anchor="t"/>
+          <a:lstStyle/>
+          <a:p>
+            <a:pPr algn="l" indent="0" marL="0">
               <a:lnSpc>
                 <a:spcPts val="2080"/>
               </a:lnSpc>
               <a:spcAft>
                 <a:spcPts val="1000"/>
               </a:spcAft>
-              <a:buSzPct val="100000"/>
-              <a:buChar char="•"/>
-            </a:pPr>
-            <a:r>
-              <a:rPr lang="en-US" sz="1600" b="1" dirty="0">
+              <a:buNone/>
+            </a:pPr>
+            <a:r>
+              <a:rPr lang="en-US" sz="1600" dirty="0">
                 <a:solidFill>
                   <a:srgbClr val="CBD5E1"/>
                 </a:solidFill>
@@ -3280,7 +3881,7 @@
                 <a:ea typeface="Arial" pitchFamily="34" charset="-122"/>
                 <a:cs typeface="Arial" pitchFamily="34" charset="-120"/>
               </a:rPr>
-              <a:t>AI-assisted planning:</a:t>
+              <a:t>• </a:t>
             </a:r>
             <a:pPr algn="l" indent="0" marL="0">
               <a:lnSpc>
@@ -3292,7 +3893,7 @@
               <a:buNone/>
             </a:pPr>
             <a:r>
-              <a:rPr lang="en-US" sz="1600" dirty="0">
+              <a:rPr lang="en-US" sz="1600" b="1" dirty="0">
                 <a:solidFill>
                   <a:srgbClr val="CBD5E1"/>
                 </a:solidFill>
@@ -3300,23 +3901,19 @@
                 <a:ea typeface="Arial" pitchFamily="34" charset="-122"/>
                 <a:cs typeface="Arial" pitchFamily="34" charset="-120"/>
               </a:rPr>
-              <a:t> Complex shell/file operations generated locally.</a:t>
-            </a:r>
-            <a:endParaRPr lang="en-US" sz="1600" dirty="0"/>
-          </a:p>
-          <a:p>
-            <a:pPr algn="l" marL="127000" indent="-127000">
+              <a:t>AI-assisted planning:</a:t>
+            </a:r>
+            <a:pPr algn="l" indent="0" marL="0">
               <a:lnSpc>
                 <a:spcPts val="2080"/>
               </a:lnSpc>
               <a:spcAft>
                 <a:spcPts val="1000"/>
               </a:spcAft>
-              <a:buSzPct val="100000"/>
-              <a:buChar char="•"/>
-            </a:pPr>
-            <a:r>
-              <a:rPr lang="en-US" sz="1600" b="1" dirty="0">
+              <a:buNone/>
+            </a:pPr>
+            <a:r>
+              <a:rPr lang="en-US" sz="1600" dirty="0">
                 <a:solidFill>
                   <a:srgbClr val="CBD5E1"/>
                 </a:solidFill>
@@ -3324,8 +3921,33 @@
                 <a:ea typeface="Arial" pitchFamily="34" charset="-122"/>
                 <a:cs typeface="Arial" pitchFamily="34" charset="-120"/>
               </a:rPr>
-              <a:t>Human approval gates:</a:t>
-            </a:r>
+              <a:t> Complex shell/file operations generated locally.</a:t>
+            </a:r>
+            <a:endParaRPr lang="en-US" sz="1600" dirty="0"/>
+          </a:p>
+        </p:txBody>
+      </p:sp>
+      <p:sp>
+        <p:nvSpPr>
+          <p:cNvPr id="7" name="Text 5"/>
+          <p:cNvSpPr/>
+          <p:nvPr/>
+        </p:nvSpPr>
+        <p:spPr>
+          <a:xfrm>
+            <a:off x="971401" y="2635002"/>
+            <a:ext cx="7604200" cy="264021"/>
+          </a:xfrm>
+          <a:prstGeom prst="rect">
+            <a:avLst/>
+          </a:prstGeom>
+          <a:noFill/>
+          <a:ln/>
+        </p:spPr>
+        <p:txBody>
+          <a:bodyPr wrap="square" lIns="0" tIns="0" rIns="0" bIns="0" rtlCol="0" anchor="t"/>
+          <a:lstStyle/>
+          <a:p>
             <a:pPr algn="l" indent="0" marL="0">
               <a:lnSpc>
                 <a:spcPts val="2080"/>
@@ -3344,31 +3966,27 @@
                 <a:ea typeface="Arial" pitchFamily="34" charset="-122"/>
                 <a:cs typeface="Arial" pitchFamily="34" charset="-120"/>
               </a:rPr>
-              <a:t> Interactive TUI requiring explicit validation.</a:t>
-            </a:r>
-            <a:endParaRPr lang="en-US" sz="1600" dirty="0"/>
-          </a:p>
-          <a:p>
-            <a:pPr algn="l" marL="127000" indent="-127000">
+              <a:t>• </a:t>
+            </a:r>
+            <a:pPr algn="l" indent="0" marL="0">
               <a:lnSpc>
                 <a:spcPts val="2080"/>
               </a:lnSpc>
               <a:spcAft>
                 <a:spcPts val="1000"/>
               </a:spcAft>
-              <a:buSzPct val="100000"/>
-              <a:buChar char="•"/>
-            </a:pPr>
-            <a:r>
-              <a:rPr lang="en-US" sz="1500" dirty="0">
-                <a:solidFill>
-                  <a:srgbClr val="38BDF8"/>
-                </a:solidFill>
-                <a:latin typeface="Arial" pitchFamily="34" charset="0"/>
-                <a:ea typeface="Arial" pitchFamily="34" charset="-122"/>
-                <a:cs typeface="Arial" pitchFamily="34" charset="-120"/>
-              </a:rPr>
-              <a:t>SAFE MODE</a:t>
+              <a:buNone/>
+            </a:pPr>
+            <a:r>
+              <a:rPr lang="en-US" sz="1600" b="1" dirty="0">
+                <a:solidFill>
+                  <a:srgbClr val="CBD5E1"/>
+                </a:solidFill>
+                <a:latin typeface="Arial" pitchFamily="34" charset="0"/>
+                <a:ea typeface="Arial" pitchFamily="34" charset="-122"/>
+                <a:cs typeface="Arial" pitchFamily="34" charset="-120"/>
+              </a:rPr>
+              <a:t>Human approval gates:</a:t>
             </a:r>
             <a:pPr algn="l" indent="0" marL="0">
               <a:lnSpc>
@@ -3388,8 +4006,33 @@
                 <a:ea typeface="Arial" pitchFamily="34" charset="-122"/>
                 <a:cs typeface="Arial" pitchFamily="34" charset="-120"/>
               </a:rPr>
-              <a:t> </a:t>
-            </a:r>
+              <a:t> Interactive TUI requiring explicit validation.</a:t>
+            </a:r>
+            <a:endParaRPr lang="en-US" sz="1600" dirty="0"/>
+          </a:p>
+        </p:txBody>
+      </p:sp>
+      <p:sp>
+        <p:nvSpPr>
+          <p:cNvPr id="8" name="Text 6"/>
+          <p:cNvSpPr/>
+          <p:nvPr/>
+        </p:nvSpPr>
+        <p:spPr>
+          <a:xfrm>
+            <a:off x="971401" y="3025973"/>
+            <a:ext cx="7604200" cy="264021"/>
+          </a:xfrm>
+          <a:prstGeom prst="rect">
+            <a:avLst/>
+          </a:prstGeom>
+          <a:noFill/>
+          <a:ln/>
+        </p:spPr>
+        <p:txBody>
+          <a:bodyPr wrap="square" lIns="0" tIns="0" rIns="0" bIns="0" rtlCol="0" anchor="t"/>
+          <a:lstStyle/>
+          <a:p>
             <a:pPr algn="l" indent="0" marL="0">
               <a:lnSpc>
                 <a:spcPts val="2080"/>
@@ -3400,7 +4043,7 @@
               <a:buNone/>
             </a:pPr>
             <a:r>
-              <a:rPr lang="en-US" sz="1600" b="1" dirty="0">
+              <a:rPr lang="en-US" sz="1600" dirty="0">
                 <a:solidFill>
                   <a:srgbClr val="CBD5E1"/>
                 </a:solidFill>
@@ -3408,7 +4051,7 @@
                 <a:ea typeface="Arial" pitchFamily="34" charset="-122"/>
                 <a:cs typeface="Arial" pitchFamily="34" charset="-120"/>
               </a:rPr>
-              <a:t>by default:</a:t>
+              <a:t>• </a:t>
             </a:r>
             <a:pPr algn="l" indent="0" marL="0">
               <a:lnSpc>
@@ -3420,31 +4063,27 @@
               <a:buNone/>
             </a:pPr>
             <a:r>
-              <a:rPr lang="en-US" sz="1600" dirty="0">
-                <a:solidFill>
-                  <a:srgbClr val="CBD5E1"/>
-                </a:solidFill>
-                <a:latin typeface="Arial" pitchFamily="34" charset="0"/>
-                <a:ea typeface="Arial" pitchFamily="34" charset="-122"/>
-                <a:cs typeface="Arial" pitchFamily="34" charset="-120"/>
-              </a:rPr>
-              <a:t> Immutable operations until authorized.</a:t>
-            </a:r>
-            <a:endParaRPr lang="en-US" sz="1600" dirty="0"/>
-          </a:p>
-          <a:p>
-            <a:pPr algn="l" marL="127000" indent="-127000">
+              <a:rPr lang="en-US" sz="1500" dirty="0">
+                <a:solidFill>
+                  <a:srgbClr val="38BDF8"/>
+                </a:solidFill>
+                <a:latin typeface="Arial" pitchFamily="34" charset="0"/>
+                <a:ea typeface="Arial" pitchFamily="34" charset="-122"/>
+                <a:cs typeface="Arial" pitchFamily="34" charset="-120"/>
+              </a:rPr>
+              <a:t>SAFE MODE</a:t>
+            </a:r>
+            <a:pPr algn="l" indent="0" marL="0">
               <a:lnSpc>
                 <a:spcPts val="2080"/>
               </a:lnSpc>
               <a:spcAft>
                 <a:spcPts val="1000"/>
               </a:spcAft>
-              <a:buSzPct val="100000"/>
-              <a:buChar char="•"/>
-            </a:pPr>
-            <a:r>
-              <a:rPr lang="en-US" sz="1600" b="1" dirty="0">
+              <a:buNone/>
+            </a:pPr>
+            <a:r>
+              <a:rPr lang="en-US" sz="1600" dirty="0">
                 <a:solidFill>
                   <a:srgbClr val="CBD5E1"/>
                 </a:solidFill>
@@ -3452,7 +4091,7 @@
                 <a:ea typeface="Arial" pitchFamily="34" charset="-122"/>
                 <a:cs typeface="Arial" pitchFamily="34" charset="-120"/>
               </a:rPr>
-              <a:t>Deterministic execution:</a:t>
+              <a:t> </a:t>
             </a:r>
             <a:pPr algn="l" indent="0" marL="0">
               <a:lnSpc>
@@ -3464,7 +4103,7 @@
               <a:buNone/>
             </a:pPr>
             <a:r>
-              <a:rPr lang="en-US" sz="1600" dirty="0">
+              <a:rPr lang="en-US" sz="1600" b="1" dirty="0">
                 <a:solidFill>
                   <a:srgbClr val="CBD5E1"/>
                 </a:solidFill>
@@ -3472,20 +4111,166 @@
                 <a:ea typeface="Arial" pitchFamily="34" charset="-122"/>
                 <a:cs typeface="Arial" pitchFamily="34" charset="-120"/>
               </a:rPr>
-              <a:t> Predictable, step-by-step pipeline resolution.</a:t>
-            </a:r>
-            <a:endParaRPr lang="en-US" sz="1600" dirty="0"/>
-          </a:p>
-          <a:p>
-            <a:pPr algn="l" marL="127000" indent="-127000">
+              <a:t>by default:</a:t>
+            </a:r>
+            <a:pPr algn="l" indent="0" marL="0">
               <a:lnSpc>
                 <a:spcPts val="2080"/>
               </a:lnSpc>
               <a:spcAft>
                 <a:spcPts val="1000"/>
               </a:spcAft>
-              <a:buSzPct val="100000"/>
-              <a:buChar char="•"/>
+              <a:buNone/>
+            </a:pPr>
+            <a:r>
+              <a:rPr lang="en-US" sz="1600" dirty="0">
+                <a:solidFill>
+                  <a:srgbClr val="CBD5E1"/>
+                </a:solidFill>
+                <a:latin typeface="Arial" pitchFamily="34" charset="0"/>
+                <a:ea typeface="Arial" pitchFamily="34" charset="-122"/>
+                <a:cs typeface="Arial" pitchFamily="34" charset="-120"/>
+              </a:rPr>
+              <a:t> Immutable operations until authorized.</a:t>
+            </a:r>
+            <a:endParaRPr lang="en-US" sz="1600" dirty="0"/>
+          </a:p>
+        </p:txBody>
+      </p:sp>
+      <p:sp>
+        <p:nvSpPr>
+          <p:cNvPr id="9" name="Text 7"/>
+          <p:cNvSpPr/>
+          <p:nvPr/>
+        </p:nvSpPr>
+        <p:spPr>
+          <a:xfrm>
+            <a:off x="971401" y="3416945"/>
+            <a:ext cx="7604200" cy="264021"/>
+          </a:xfrm>
+          <a:prstGeom prst="rect">
+            <a:avLst/>
+          </a:prstGeom>
+          <a:noFill/>
+          <a:ln/>
+        </p:spPr>
+        <p:txBody>
+          <a:bodyPr wrap="square" lIns="0" tIns="0" rIns="0" bIns="0" rtlCol="0" anchor="t"/>
+          <a:lstStyle/>
+          <a:p>
+            <a:pPr algn="l" indent="0" marL="0">
+              <a:lnSpc>
+                <a:spcPts val="2080"/>
+              </a:lnSpc>
+              <a:spcAft>
+                <a:spcPts val="1000"/>
+              </a:spcAft>
+              <a:buNone/>
+            </a:pPr>
+            <a:r>
+              <a:rPr lang="en-US" sz="1600" dirty="0">
+                <a:solidFill>
+                  <a:srgbClr val="CBD5E1"/>
+                </a:solidFill>
+                <a:latin typeface="Arial" pitchFamily="34" charset="0"/>
+                <a:ea typeface="Arial" pitchFamily="34" charset="-122"/>
+                <a:cs typeface="Arial" pitchFamily="34" charset="-120"/>
+              </a:rPr>
+              <a:t>• </a:t>
+            </a:r>
+            <a:pPr algn="l" indent="0" marL="0">
+              <a:lnSpc>
+                <a:spcPts val="2080"/>
+              </a:lnSpc>
+              <a:spcAft>
+                <a:spcPts val="1000"/>
+              </a:spcAft>
+              <a:buNone/>
+            </a:pPr>
+            <a:r>
+              <a:rPr lang="en-US" sz="1600" b="1" dirty="0">
+                <a:solidFill>
+                  <a:srgbClr val="CBD5E1"/>
+                </a:solidFill>
+                <a:latin typeface="Arial" pitchFamily="34" charset="0"/>
+                <a:ea typeface="Arial" pitchFamily="34" charset="-122"/>
+                <a:cs typeface="Arial" pitchFamily="34" charset="-120"/>
+              </a:rPr>
+              <a:t>Deterministic execution:</a:t>
+            </a:r>
+            <a:pPr algn="l" indent="0" marL="0">
+              <a:lnSpc>
+                <a:spcPts val="2080"/>
+              </a:lnSpc>
+              <a:spcAft>
+                <a:spcPts val="1000"/>
+              </a:spcAft>
+              <a:buNone/>
+            </a:pPr>
+            <a:r>
+              <a:rPr lang="en-US" sz="1600" dirty="0">
+                <a:solidFill>
+                  <a:srgbClr val="CBD5E1"/>
+                </a:solidFill>
+                <a:latin typeface="Arial" pitchFamily="34" charset="0"/>
+                <a:ea typeface="Arial" pitchFamily="34" charset="-122"/>
+                <a:cs typeface="Arial" pitchFamily="34" charset="-120"/>
+              </a:rPr>
+              <a:t> Predictable, step-by-step pipeline resolution.</a:t>
+            </a:r>
+            <a:endParaRPr lang="en-US" sz="1600" dirty="0"/>
+          </a:p>
+        </p:txBody>
+      </p:sp>
+      <p:sp>
+        <p:nvSpPr>
+          <p:cNvPr id="10" name="Text 8"/>
+          <p:cNvSpPr/>
+          <p:nvPr/>
+        </p:nvSpPr>
+        <p:spPr>
+          <a:xfrm>
+            <a:off x="971401" y="3807916"/>
+            <a:ext cx="7604200" cy="264021"/>
+          </a:xfrm>
+          <a:prstGeom prst="rect">
+            <a:avLst/>
+          </a:prstGeom>
+          <a:noFill/>
+          <a:ln/>
+        </p:spPr>
+        <p:txBody>
+          <a:bodyPr wrap="square" lIns="0" tIns="0" rIns="0" bIns="0" rtlCol="0" anchor="t"/>
+          <a:lstStyle/>
+          <a:p>
+            <a:pPr algn="l" indent="0" marL="0">
+              <a:lnSpc>
+                <a:spcPts val="2080"/>
+              </a:lnSpc>
+              <a:spcAft>
+                <a:spcPts val="1000"/>
+              </a:spcAft>
+              <a:buNone/>
+            </a:pPr>
+            <a:r>
+              <a:rPr lang="en-US" sz="1600" dirty="0">
+                <a:solidFill>
+                  <a:srgbClr val="CBD5E1"/>
+                </a:solidFill>
+                <a:latin typeface="Arial" pitchFamily="34" charset="0"/>
+                <a:ea typeface="Arial" pitchFamily="34" charset="-122"/>
+                <a:cs typeface="Arial" pitchFamily="34" charset="-120"/>
+              </a:rPr>
+              <a:t>• </a:t>
+            </a:r>
+            <a:pPr algn="l" indent="0" marL="0">
+              <a:lnSpc>
+                <a:spcPts val="2080"/>
+              </a:lnSpc>
+              <a:spcAft>
+                <a:spcPts val="1000"/>
+              </a:spcAft>
+              <a:buNone/>
             </a:pPr>
             <a:r>
               <a:rPr lang="en-US" sz="1600" b="1" dirty="0">
@@ -5507,31 +6292,30 @@
         </p:nvSpPr>
         <p:spPr>
           <a:xfrm>
-            <a:off x="717500" y="2307431"/>
-            <a:ext cx="7708999" cy="1563886"/>
-          </a:xfrm>
-          <a:prstGeom prst="rect">
-            <a:avLst/>
-          </a:prstGeom>
-          <a:noFill/>
-          <a:ln/>
-        </p:spPr>
-        <p:txBody>
-          <a:bodyPr wrap="square" lIns="127000" tIns="0" rIns="0" bIns="0" rtlCol="0" anchor="t"/>
-          <a:lstStyle/>
-          <a:p>
-            <a:pPr algn="l" marL="127000" indent="-127000">
+            <a:off x="971401" y="2244030"/>
+            <a:ext cx="7604200" cy="264021"/>
+          </a:xfrm>
+          <a:prstGeom prst="rect">
+            <a:avLst/>
+          </a:prstGeom>
+          <a:noFill/>
+          <a:ln/>
+        </p:spPr>
+        <p:txBody>
+          <a:bodyPr wrap="square" lIns="0" tIns="0" rIns="0" bIns="0" rtlCol="0" anchor="t"/>
+          <a:lstStyle/>
+          <a:p>
+            <a:pPr algn="l" indent="0" marL="0">
               <a:lnSpc>
                 <a:spcPts val="2080"/>
               </a:lnSpc>
               <a:spcAft>
                 <a:spcPts val="1000"/>
               </a:spcAft>
-              <a:buSzPct val="100000"/>
-              <a:buChar char="•"/>
-            </a:pPr>
-            <a:r>
-              <a:rPr lang="en-US" sz="1600" b="1" dirty="0">
+              <a:buNone/>
+            </a:pPr>
+            <a:r>
+              <a:rPr lang="en-US" sz="1600" dirty="0">
                 <a:solidFill>
                   <a:srgbClr val="CBD5E1"/>
                 </a:solidFill>
@@ -5539,7 +6323,7 @@
                 <a:ea typeface="Arial" pitchFamily="34" charset="-122"/>
                 <a:cs typeface="Arial" pitchFamily="34" charset="-120"/>
               </a:rPr>
-              <a:t>Workspace Boundaries:</a:t>
+              <a:t>• </a:t>
             </a:r>
             <a:pPr algn="l" indent="0" marL="0">
               <a:lnSpc>
@@ -5551,7 +6335,7 @@
               <a:buNone/>
             </a:pPr>
             <a:r>
-              <a:rPr lang="en-US" sz="1600" dirty="0">
+              <a:rPr lang="en-US" sz="1600" b="1" dirty="0">
                 <a:solidFill>
                   <a:srgbClr val="CBD5E1"/>
                 </a:solidFill>
@@ -5559,23 +6343,19 @@
                 <a:ea typeface="Arial" pitchFamily="34" charset="-122"/>
                 <a:cs typeface="Arial" pitchFamily="34" charset="-120"/>
               </a:rPr>
-              <a:t> Strict directory limits prevent path traversal escapes.</a:t>
-            </a:r>
-            <a:endParaRPr lang="en-US" sz="1600" dirty="0"/>
-          </a:p>
-          <a:p>
-            <a:pPr algn="l" marL="127000" indent="-127000">
+              <a:t>Workspace Boundaries:</a:t>
+            </a:r>
+            <a:pPr algn="l" indent="0" marL="0">
               <a:lnSpc>
                 <a:spcPts val="2080"/>
               </a:lnSpc>
               <a:spcAft>
                 <a:spcPts val="1000"/>
               </a:spcAft>
-              <a:buSzPct val="100000"/>
-              <a:buChar char="•"/>
-            </a:pPr>
-            <a:r>
-              <a:rPr lang="en-US" sz="1600" b="1" dirty="0">
+              <a:buNone/>
+            </a:pPr>
+            <a:r>
+              <a:rPr lang="en-US" sz="1600" dirty="0">
                 <a:solidFill>
                   <a:srgbClr val="CBD5E1"/>
                 </a:solidFill>
@@ -5583,8 +6363,33 @@
                 <a:ea typeface="Arial" pitchFamily="34" charset="-122"/>
                 <a:cs typeface="Arial" pitchFamily="34" charset="-120"/>
               </a:rPr>
-              <a:t>Secret Redaction:</a:t>
-            </a:r>
+              <a:t> Strict directory limits prevent path traversal escapes.</a:t>
+            </a:r>
+            <a:endParaRPr lang="en-US" sz="1600" dirty="0"/>
+          </a:p>
+        </p:txBody>
+      </p:sp>
+      <p:sp>
+        <p:nvSpPr>
+          <p:cNvPr id="7" name="Text 5"/>
+          <p:cNvSpPr/>
+          <p:nvPr/>
+        </p:nvSpPr>
+        <p:spPr>
+          <a:xfrm>
+            <a:off x="971401" y="2635002"/>
+            <a:ext cx="7604200" cy="264021"/>
+          </a:xfrm>
+          <a:prstGeom prst="rect">
+            <a:avLst/>
+          </a:prstGeom>
+          <a:noFill/>
+          <a:ln/>
+        </p:spPr>
+        <p:txBody>
+          <a:bodyPr wrap="square" lIns="0" tIns="0" rIns="0" bIns="0" rtlCol="0" anchor="t"/>
+          <a:lstStyle/>
+          <a:p>
             <a:pPr algn="l" indent="0" marL="0">
               <a:lnSpc>
                 <a:spcPts val="2080"/>
@@ -5603,20 +6408,16 @@
                 <a:ea typeface="Arial" pitchFamily="34" charset="-122"/>
                 <a:cs typeface="Arial" pitchFamily="34" charset="-120"/>
               </a:rPr>
-              <a:t> Active filtering of `.env` strings in stdout.</a:t>
-            </a:r>
-            <a:endParaRPr lang="en-US" sz="1600" dirty="0"/>
-          </a:p>
-          <a:p>
-            <a:pPr algn="l" marL="127000" indent="-127000">
+              <a:t>• </a:t>
+            </a:r>
+            <a:pPr algn="l" indent="0" marL="0">
               <a:lnSpc>
                 <a:spcPts val="2080"/>
               </a:lnSpc>
               <a:spcAft>
                 <a:spcPts val="1000"/>
               </a:spcAft>
-              <a:buSzPct val="100000"/>
-              <a:buChar char="•"/>
+              <a:buNone/>
             </a:pPr>
             <a:r>
               <a:rPr lang="en-US" sz="1600" b="1" dirty="0">
@@ -5627,7 +6428,7 @@
                 <a:ea typeface="Arial" pitchFamily="34" charset="-122"/>
                 <a:cs typeface="Arial" pitchFamily="34" charset="-120"/>
               </a:rPr>
-              <a:t>Atomic Writes:</a:t>
+              <a:t>Secret Redaction:</a:t>
             </a:r>
             <a:pPr algn="l" indent="0" marL="0">
               <a:lnSpc>
@@ -5647,20 +6448,146 @@
                 <a:ea typeface="Arial" pitchFamily="34" charset="-122"/>
                 <a:cs typeface="Arial" pitchFamily="34" charset="-120"/>
               </a:rPr>
-              <a:t> Safe configuration persistence dodging OS locks.</a:t>
+              <a:t> Active filtering of `.env` strings in stdout.</a:t>
             </a:r>
             <a:endParaRPr lang="en-US" sz="1600" dirty="0"/>
           </a:p>
-          <a:p>
-            <a:pPr algn="l" marL="127000" indent="-127000">
+        </p:txBody>
+      </p:sp>
+      <p:sp>
+        <p:nvSpPr>
+          <p:cNvPr id="8" name="Text 6"/>
+          <p:cNvSpPr/>
+          <p:nvPr/>
+        </p:nvSpPr>
+        <p:spPr>
+          <a:xfrm>
+            <a:off x="971401" y="3025973"/>
+            <a:ext cx="7604200" cy="264021"/>
+          </a:xfrm>
+          <a:prstGeom prst="rect">
+            <a:avLst/>
+          </a:prstGeom>
+          <a:noFill/>
+          <a:ln/>
+        </p:spPr>
+        <p:txBody>
+          <a:bodyPr wrap="square" lIns="0" tIns="0" rIns="0" bIns="0" rtlCol="0" anchor="t"/>
+          <a:lstStyle/>
+          <a:p>
+            <a:pPr algn="l" indent="0" marL="0">
               <a:lnSpc>
                 <a:spcPts val="2080"/>
               </a:lnSpc>
               <a:spcAft>
                 <a:spcPts val="1000"/>
               </a:spcAft>
-              <a:buSzPct val="100000"/>
-              <a:buChar char="•"/>
+              <a:buNone/>
+            </a:pPr>
+            <a:r>
+              <a:rPr lang="en-US" sz="1600" dirty="0">
+                <a:solidFill>
+                  <a:srgbClr val="CBD5E1"/>
+                </a:solidFill>
+                <a:latin typeface="Arial" pitchFamily="34" charset="0"/>
+                <a:ea typeface="Arial" pitchFamily="34" charset="-122"/>
+                <a:cs typeface="Arial" pitchFamily="34" charset="-120"/>
+              </a:rPr>
+              <a:t>• </a:t>
+            </a:r>
+            <a:pPr algn="l" indent="0" marL="0">
+              <a:lnSpc>
+                <a:spcPts val="2080"/>
+              </a:lnSpc>
+              <a:spcAft>
+                <a:spcPts val="1000"/>
+              </a:spcAft>
+              <a:buNone/>
+            </a:pPr>
+            <a:r>
+              <a:rPr lang="en-US" sz="1600" b="1" dirty="0">
+                <a:solidFill>
+                  <a:srgbClr val="CBD5E1"/>
+                </a:solidFill>
+                <a:latin typeface="Arial" pitchFamily="34" charset="0"/>
+                <a:ea typeface="Arial" pitchFamily="34" charset="-122"/>
+                <a:cs typeface="Arial" pitchFamily="34" charset="-120"/>
+              </a:rPr>
+              <a:t>Atomic Writes:</a:t>
+            </a:r>
+            <a:pPr algn="l" indent="0" marL="0">
+              <a:lnSpc>
+                <a:spcPts val="2080"/>
+              </a:lnSpc>
+              <a:spcAft>
+                <a:spcPts val="1000"/>
+              </a:spcAft>
+              <a:buNone/>
+            </a:pPr>
+            <a:r>
+              <a:rPr lang="en-US" sz="1600" dirty="0">
+                <a:solidFill>
+                  <a:srgbClr val="CBD5E1"/>
+                </a:solidFill>
+                <a:latin typeface="Arial" pitchFamily="34" charset="0"/>
+                <a:ea typeface="Arial" pitchFamily="34" charset="-122"/>
+                <a:cs typeface="Arial" pitchFamily="34" charset="-120"/>
+              </a:rPr>
+              <a:t> Safe configuration persistence dodging OS locks.</a:t>
+            </a:r>
+            <a:endParaRPr lang="en-US" sz="1600" dirty="0"/>
+          </a:p>
+        </p:txBody>
+      </p:sp>
+      <p:sp>
+        <p:nvSpPr>
+          <p:cNvPr id="9" name="Text 7"/>
+          <p:cNvSpPr/>
+          <p:nvPr/>
+        </p:nvSpPr>
+        <p:spPr>
+          <a:xfrm>
+            <a:off x="971401" y="3416945"/>
+            <a:ext cx="7604200" cy="264021"/>
+          </a:xfrm>
+          <a:prstGeom prst="rect">
+            <a:avLst/>
+          </a:prstGeom>
+          <a:noFill/>
+          <a:ln/>
+        </p:spPr>
+        <p:txBody>
+          <a:bodyPr wrap="square" lIns="0" tIns="0" rIns="0" bIns="0" rtlCol="0" anchor="t"/>
+          <a:lstStyle/>
+          <a:p>
+            <a:pPr algn="l" indent="0" marL="0">
+              <a:lnSpc>
+                <a:spcPts val="2080"/>
+              </a:lnSpc>
+              <a:spcAft>
+                <a:spcPts val="1000"/>
+              </a:spcAft>
+              <a:buNone/>
+            </a:pPr>
+            <a:r>
+              <a:rPr lang="en-US" sz="1600" dirty="0">
+                <a:solidFill>
+                  <a:srgbClr val="CBD5E1"/>
+                </a:solidFill>
+                <a:latin typeface="Arial" pitchFamily="34" charset="0"/>
+                <a:ea typeface="Arial" pitchFamily="34" charset="-122"/>
+                <a:cs typeface="Arial" pitchFamily="34" charset="-120"/>
+              </a:rPr>
+              <a:t>• </a:t>
+            </a:r>
+            <a:pPr algn="l" indent="0" marL="0">
+              <a:lnSpc>
+                <a:spcPts val="2080"/>
+              </a:lnSpc>
+              <a:spcAft>
+                <a:spcPts val="1000"/>
+              </a:spcAft>
+              <a:buNone/>
             </a:pPr>
             <a:r>
               <a:rPr lang="en-US" sz="1600" b="1" dirty="0">
@@ -5893,31 +6820,30 @@
         </p:nvSpPr>
         <p:spPr>
           <a:xfrm>
-            <a:off x="717500" y="2307431"/>
-            <a:ext cx="7708999" cy="1563886"/>
-          </a:xfrm>
-          <a:prstGeom prst="rect">
-            <a:avLst/>
-          </a:prstGeom>
-          <a:noFill/>
-          <a:ln/>
-        </p:spPr>
-        <p:txBody>
-          <a:bodyPr wrap="square" lIns="127000" tIns="0" rIns="0" bIns="0" rtlCol="0" anchor="t"/>
-          <a:lstStyle/>
-          <a:p>
-            <a:pPr algn="l" marL="127000" indent="-127000">
+            <a:off x="971401" y="2244030"/>
+            <a:ext cx="7604200" cy="264021"/>
+          </a:xfrm>
+          <a:prstGeom prst="rect">
+            <a:avLst/>
+          </a:prstGeom>
+          <a:noFill/>
+          <a:ln/>
+        </p:spPr>
+        <p:txBody>
+          <a:bodyPr wrap="square" lIns="0" tIns="0" rIns="0" bIns="0" rtlCol="0" anchor="t"/>
+          <a:lstStyle/>
+          <a:p>
+            <a:pPr algn="l" indent="0" marL="0">
               <a:lnSpc>
                 <a:spcPts val="2080"/>
               </a:lnSpc>
               <a:spcAft>
                 <a:spcPts val="1000"/>
               </a:spcAft>
-              <a:buSzPct val="100000"/>
-              <a:buChar char="•"/>
-            </a:pPr>
-            <a:r>
-              <a:rPr lang="en-US" sz="1600" b="1" dirty="0">
+              <a:buNone/>
+            </a:pPr>
+            <a:r>
+              <a:rPr lang="en-US" sz="1600" dirty="0">
                 <a:solidFill>
                   <a:srgbClr val="CBD5E1"/>
                 </a:solidFill>
@@ -5925,7 +6851,7 @@
                 <a:ea typeface="Arial" pitchFamily="34" charset="-122"/>
                 <a:cs typeface="Arial" pitchFamily="34" charset="-120"/>
               </a:rPr>
-              <a:t>Execution Limiter:</a:t>
+              <a:t>• </a:t>
             </a:r>
             <a:pPr algn="l" indent="0" marL="0">
               <a:lnSpc>
@@ -5937,7 +6863,7 @@
               <a:buNone/>
             </a:pPr>
             <a:r>
-              <a:rPr lang="en-US" sz="1600" dirty="0">
+              <a:rPr lang="en-US" sz="1600" b="1" dirty="0">
                 <a:solidFill>
                   <a:srgbClr val="CBD5E1"/>
                 </a:solidFill>
@@ -5945,23 +6871,19 @@
                 <a:ea typeface="Arial" pitchFamily="34" charset="-122"/>
                 <a:cs typeface="Arial" pitchFamily="34" charset="-120"/>
               </a:rPr>
-              <a:t> Global semaphores prevent parallel OOM crashes.</a:t>
-            </a:r>
-            <a:endParaRPr lang="en-US" sz="1600" dirty="0"/>
-          </a:p>
-          <a:p>
-            <a:pPr algn="l" marL="127000" indent="-127000">
+              <a:t>Execution Limiter:</a:t>
+            </a:r>
+            <a:pPr algn="l" indent="0" marL="0">
               <a:lnSpc>
                 <a:spcPts val="2080"/>
               </a:lnSpc>
               <a:spcAft>
                 <a:spcPts val="1000"/>
               </a:spcAft>
-              <a:buSzPct val="100000"/>
-              <a:buChar char="•"/>
-            </a:pPr>
-            <a:r>
-              <a:rPr lang="en-US" sz="1600" b="1" dirty="0">
+              <a:buNone/>
+            </a:pPr>
+            <a:r>
+              <a:rPr lang="en-US" sz="1600" dirty="0">
                 <a:solidFill>
                   <a:srgbClr val="CBD5E1"/>
                 </a:solidFill>
@@ -5969,8 +6891,33 @@
                 <a:ea typeface="Arial" pitchFamily="34" charset="-122"/>
                 <a:cs typeface="Arial" pitchFamily="34" charset="-120"/>
               </a:rPr>
-              <a:t>Config Recovery:</a:t>
-            </a:r>
+              <a:t> Global semaphores prevent parallel OOM crashes.</a:t>
+            </a:r>
+            <a:endParaRPr lang="en-US" sz="1600" dirty="0"/>
+          </a:p>
+        </p:txBody>
+      </p:sp>
+      <p:sp>
+        <p:nvSpPr>
+          <p:cNvPr id="7" name="Text 5"/>
+          <p:cNvSpPr/>
+          <p:nvPr/>
+        </p:nvSpPr>
+        <p:spPr>
+          <a:xfrm>
+            <a:off x="971401" y="2635002"/>
+            <a:ext cx="7604200" cy="264021"/>
+          </a:xfrm>
+          <a:prstGeom prst="rect">
+            <a:avLst/>
+          </a:prstGeom>
+          <a:noFill/>
+          <a:ln/>
+        </p:spPr>
+        <p:txBody>
+          <a:bodyPr wrap="square" lIns="0" tIns="0" rIns="0" bIns="0" rtlCol="0" anchor="t"/>
+          <a:lstStyle/>
+          <a:p>
             <a:pPr algn="l" indent="0" marL="0">
               <a:lnSpc>
                 <a:spcPts val="2080"/>
@@ -5989,20 +6936,16 @@
                 <a:ea typeface="Arial" pitchFamily="34" charset="-122"/>
                 <a:cs typeface="Arial" pitchFamily="34" charset="-120"/>
               </a:rPr>
-              <a:t> Automatic isolation and self-healing `.corrupt` configurations.</a:t>
-            </a:r>
-            <a:endParaRPr lang="en-US" sz="1600" dirty="0"/>
-          </a:p>
-          <a:p>
-            <a:pPr algn="l" marL="127000" indent="-127000">
+              <a:t>• </a:t>
+            </a:r>
+            <a:pPr algn="l" indent="0" marL="0">
               <a:lnSpc>
                 <a:spcPts val="2080"/>
               </a:lnSpc>
               <a:spcAft>
                 <a:spcPts val="1000"/>
               </a:spcAft>
-              <a:buSzPct val="100000"/>
-              <a:buChar char="•"/>
+              <a:buNone/>
             </a:pPr>
             <a:r>
               <a:rPr lang="en-US" sz="1600" b="1" dirty="0">
@@ -6013,7 +6956,7 @@
                 <a:ea typeface="Arial" pitchFamily="34" charset="-122"/>
                 <a:cs typeface="Arial" pitchFamily="34" charset="-120"/>
               </a:rPr>
-              <a:t>Terminal Restoration:</a:t>
+              <a:t>Config Recovery:</a:t>
             </a:r>
             <a:pPr algn="l" indent="0" marL="0">
               <a:lnSpc>
@@ -6033,20 +6976,146 @@
                 <a:ea typeface="Arial" pitchFamily="34" charset="-122"/>
                 <a:cs typeface="Arial" pitchFamily="34" charset="-120"/>
               </a:rPr>
-              <a:t> Guaranteed ANSI cursor reset on fatal exit.</a:t>
+              <a:t> Automatic isolation and self-healing `.corrupt` configurations.</a:t>
             </a:r>
             <a:endParaRPr lang="en-US" sz="1600" dirty="0"/>
           </a:p>
-          <a:p>
-            <a:pPr algn="l" marL="127000" indent="-127000">
+        </p:txBody>
+      </p:sp>
+      <p:sp>
+        <p:nvSpPr>
+          <p:cNvPr id="8" name="Text 6"/>
+          <p:cNvSpPr/>
+          <p:nvPr/>
+        </p:nvSpPr>
+        <p:spPr>
+          <a:xfrm>
+            <a:off x="971401" y="3025973"/>
+            <a:ext cx="7604200" cy="264021"/>
+          </a:xfrm>
+          <a:prstGeom prst="rect">
+            <a:avLst/>
+          </a:prstGeom>
+          <a:noFill/>
+          <a:ln/>
+        </p:spPr>
+        <p:txBody>
+          <a:bodyPr wrap="square" lIns="0" tIns="0" rIns="0" bIns="0" rtlCol="0" anchor="t"/>
+          <a:lstStyle/>
+          <a:p>
+            <a:pPr algn="l" indent="0" marL="0">
               <a:lnSpc>
                 <a:spcPts val="2080"/>
               </a:lnSpc>
               <a:spcAft>
                 <a:spcPts val="1000"/>
               </a:spcAft>
-              <a:buSzPct val="100000"/>
-              <a:buChar char="•"/>
+              <a:buNone/>
+            </a:pPr>
+            <a:r>
+              <a:rPr lang="en-US" sz="1600" dirty="0">
+                <a:solidFill>
+                  <a:srgbClr val="CBD5E1"/>
+                </a:solidFill>
+                <a:latin typeface="Arial" pitchFamily="34" charset="0"/>
+                <a:ea typeface="Arial" pitchFamily="34" charset="-122"/>
+                <a:cs typeface="Arial" pitchFamily="34" charset="-120"/>
+              </a:rPr>
+              <a:t>• </a:t>
+            </a:r>
+            <a:pPr algn="l" indent="0" marL="0">
+              <a:lnSpc>
+                <a:spcPts val="2080"/>
+              </a:lnSpc>
+              <a:spcAft>
+                <a:spcPts val="1000"/>
+              </a:spcAft>
+              <a:buNone/>
+            </a:pPr>
+            <a:r>
+              <a:rPr lang="en-US" sz="1600" b="1" dirty="0">
+                <a:solidFill>
+                  <a:srgbClr val="CBD5E1"/>
+                </a:solidFill>
+                <a:latin typeface="Arial" pitchFamily="34" charset="0"/>
+                <a:ea typeface="Arial" pitchFamily="34" charset="-122"/>
+                <a:cs typeface="Arial" pitchFamily="34" charset="-120"/>
+              </a:rPr>
+              <a:t>Terminal Restoration:</a:t>
+            </a:r>
+            <a:pPr algn="l" indent="0" marL="0">
+              <a:lnSpc>
+                <a:spcPts val="2080"/>
+              </a:lnSpc>
+              <a:spcAft>
+                <a:spcPts val="1000"/>
+              </a:spcAft>
+              <a:buNone/>
+            </a:pPr>
+            <a:r>
+              <a:rPr lang="en-US" sz="1600" dirty="0">
+                <a:solidFill>
+                  <a:srgbClr val="CBD5E1"/>
+                </a:solidFill>
+                <a:latin typeface="Arial" pitchFamily="34" charset="0"/>
+                <a:ea typeface="Arial" pitchFamily="34" charset="-122"/>
+                <a:cs typeface="Arial" pitchFamily="34" charset="-120"/>
+              </a:rPr>
+              <a:t> Guaranteed ANSI cursor reset on fatal exit.</a:t>
+            </a:r>
+            <a:endParaRPr lang="en-US" sz="1600" dirty="0"/>
+          </a:p>
+        </p:txBody>
+      </p:sp>
+      <p:sp>
+        <p:nvSpPr>
+          <p:cNvPr id="9" name="Text 7"/>
+          <p:cNvSpPr/>
+          <p:nvPr/>
+        </p:nvSpPr>
+        <p:spPr>
+          <a:xfrm>
+            <a:off x="971401" y="3416945"/>
+            <a:ext cx="7604200" cy="264021"/>
+          </a:xfrm>
+          <a:prstGeom prst="rect">
+            <a:avLst/>
+          </a:prstGeom>
+          <a:noFill/>
+          <a:ln/>
+        </p:spPr>
+        <p:txBody>
+          <a:bodyPr wrap="square" lIns="0" tIns="0" rIns="0" bIns="0" rtlCol="0" anchor="t"/>
+          <a:lstStyle/>
+          <a:p>
+            <a:pPr algn="l" indent="0" marL="0">
+              <a:lnSpc>
+                <a:spcPts val="2080"/>
+              </a:lnSpc>
+              <a:spcAft>
+                <a:spcPts val="1000"/>
+              </a:spcAft>
+              <a:buNone/>
+            </a:pPr>
+            <a:r>
+              <a:rPr lang="en-US" sz="1600" dirty="0">
+                <a:solidFill>
+                  <a:srgbClr val="CBD5E1"/>
+                </a:solidFill>
+                <a:latin typeface="Arial" pitchFamily="34" charset="0"/>
+                <a:ea typeface="Arial" pitchFamily="34" charset="-122"/>
+                <a:cs typeface="Arial" pitchFamily="34" charset="-120"/>
+              </a:rPr>
+              <a:t>• </a:t>
+            </a:r>
+            <a:pPr algn="l" indent="0" marL="0">
+              <a:lnSpc>
+                <a:spcPts val="2080"/>
+              </a:lnSpc>
+              <a:spcAft>
+                <a:spcPts val="1000"/>
+              </a:spcAft>
+              <a:buNone/>
             </a:pPr>
             <a:r>
               <a:rPr lang="en-US" sz="1600" b="1" dirty="0">
@@ -7089,28 +8158,27 @@
         </p:nvSpPr>
         <p:spPr>
           <a:xfrm>
-            <a:off x="507950" y="3119884"/>
-            <a:ext cx="8128099" cy="1827907"/>
-          </a:xfrm>
-          <a:prstGeom prst="rect">
-            <a:avLst/>
-          </a:prstGeom>
-          <a:noFill/>
-          <a:ln/>
-        </p:spPr>
-        <p:txBody>
-          <a:bodyPr wrap="square" lIns="127000" tIns="0" rIns="0" bIns="0" rtlCol="0" anchor="t"/>
-          <a:lstStyle/>
-          <a:p>
-            <a:pPr algn="l" marL="127000" indent="-127000">
+            <a:off x="761851" y="3119884"/>
+            <a:ext cx="8031682" cy="264021"/>
+          </a:xfrm>
+          <a:prstGeom prst="rect">
+            <a:avLst/>
+          </a:prstGeom>
+          <a:noFill/>
+          <a:ln/>
+        </p:spPr>
+        <p:txBody>
+          <a:bodyPr wrap="square" lIns="0" tIns="0" rIns="0" bIns="0" rtlCol="0" anchor="t"/>
+          <a:lstStyle/>
+          <a:p>
+            <a:pPr algn="l" indent="0" marL="0">
               <a:lnSpc>
                 <a:spcPts val="2080"/>
               </a:lnSpc>
               <a:spcAft>
                 <a:spcPts val="1000"/>
               </a:spcAft>
-              <a:buSzPct val="100000"/>
-              <a:buChar char="•"/>
+              <a:buNone/>
             </a:pPr>
             <a:r>
               <a:rPr lang="en-US" sz="1600" dirty="0">
@@ -7121,20 +8189,41 @@
                 <a:ea typeface="Arial" pitchFamily="34" charset="-122"/>
                 <a:cs typeface="Arial" pitchFamily="34" charset="-120"/>
               </a:rPr>
-              <a:t>Windows Testing (Antivirus locks, taskkill)</a:t>
+              <a:t>• Windows Testing (Antivirus locks, taskkill)</a:t>
             </a:r>
             <a:endParaRPr lang="en-US" sz="1600" dirty="0"/>
           </a:p>
-          <a:p>
-            <a:pPr algn="l" marL="127000" indent="-127000">
+        </p:txBody>
+      </p:sp>
+      <p:sp>
+        <p:nvSpPr>
+          <p:cNvPr id="10" name="Text 8"/>
+          <p:cNvSpPr/>
+          <p:nvPr/>
+        </p:nvSpPr>
+        <p:spPr>
+          <a:xfrm>
+            <a:off x="761851" y="3510855"/>
+            <a:ext cx="8031682" cy="264021"/>
+          </a:xfrm>
+          <a:prstGeom prst="rect">
+            <a:avLst/>
+          </a:prstGeom>
+          <a:noFill/>
+          <a:ln/>
+        </p:spPr>
+        <p:txBody>
+          <a:bodyPr wrap="square" lIns="0" tIns="0" rIns="0" bIns="0" rtlCol="0" anchor="t"/>
+          <a:lstStyle/>
+          <a:p>
+            <a:pPr algn="l" indent="0" marL="0">
               <a:lnSpc>
                 <a:spcPts val="2080"/>
               </a:lnSpc>
               <a:spcAft>
                 <a:spcPts val="1000"/>
               </a:spcAft>
-              <a:buSzPct val="100000"/>
-              <a:buChar char="•"/>
+              <a:buNone/>
             </a:pPr>
             <a:r>
               <a:rPr lang="en-US" sz="1600" dirty="0">
@@ -7145,20 +8234,41 @@
                 <a:ea typeface="Arial" pitchFamily="34" charset="-122"/>
                 <a:cs typeface="Arial" pitchFamily="34" charset="-120"/>
               </a:rPr>
-              <a:t>Runtime Stability (Event-loop non-blocking)</a:t>
+              <a:t>• Runtime Stability (Event-loop non-blocking)</a:t>
             </a:r>
             <a:endParaRPr lang="en-US" sz="1600" dirty="0"/>
           </a:p>
-          <a:p>
-            <a:pPr algn="l" marL="127000" indent="-127000">
+        </p:txBody>
+      </p:sp>
+      <p:sp>
+        <p:nvSpPr>
+          <p:cNvPr id="11" name="Text 9"/>
+          <p:cNvSpPr/>
+          <p:nvPr/>
+        </p:nvSpPr>
+        <p:spPr>
+          <a:xfrm>
+            <a:off x="761851" y="3901827"/>
+            <a:ext cx="8031682" cy="264021"/>
+          </a:xfrm>
+          <a:prstGeom prst="rect">
+            <a:avLst/>
+          </a:prstGeom>
+          <a:noFill/>
+          <a:ln/>
+        </p:spPr>
+        <p:txBody>
+          <a:bodyPr wrap="square" lIns="0" tIns="0" rIns="0" bIns="0" rtlCol="0" anchor="t"/>
+          <a:lstStyle/>
+          <a:p>
+            <a:pPr algn="l" indent="0" marL="0">
               <a:lnSpc>
                 <a:spcPts val="2080"/>
               </a:lnSpc>
               <a:spcAft>
                 <a:spcPts val="1000"/>
               </a:spcAft>
-              <a:buSzPct val="100000"/>
-              <a:buChar char="•"/>
+              <a:buNone/>
             </a:pPr>
             <a:r>
               <a:rPr lang="en-US" sz="1600" dirty="0">
@@ -7169,20 +8279,41 @@
                 <a:ea typeface="Arial" pitchFamily="34" charset="-122"/>
                 <a:cs typeface="Arial" pitchFamily="34" charset="-120"/>
               </a:rPr>
-              <a:t>Large Repositories (100k+ file symlink resolution)</a:t>
+              <a:t>• Large Repositories (100k+ file symlink resolution)</a:t>
             </a:r>
             <a:endParaRPr lang="en-US" sz="1600" dirty="0"/>
           </a:p>
-          <a:p>
-            <a:pPr algn="l" marL="127000" indent="-127000">
+        </p:txBody>
+      </p:sp>
+      <p:sp>
+        <p:nvSpPr>
+          <p:cNvPr id="12" name="Text 10"/>
+          <p:cNvSpPr/>
+          <p:nvPr/>
+        </p:nvSpPr>
+        <p:spPr>
+          <a:xfrm>
+            <a:off x="761851" y="4292798"/>
+            <a:ext cx="8031682" cy="264021"/>
+          </a:xfrm>
+          <a:prstGeom prst="rect">
+            <a:avLst/>
+          </a:prstGeom>
+          <a:noFill/>
+          <a:ln/>
+        </p:spPr>
+        <p:txBody>
+          <a:bodyPr wrap="square" lIns="0" tIns="0" rIns="0" bIns="0" rtlCol="0" anchor="t"/>
+          <a:lstStyle/>
+          <a:p>
+            <a:pPr algn="l" indent="0" marL="0">
               <a:lnSpc>
                 <a:spcPts val="2080"/>
               </a:lnSpc>
               <a:spcAft>
                 <a:spcPts val="1000"/>
               </a:spcAft>
-              <a:buSzPct val="100000"/>
-              <a:buChar char="•"/>
+              <a:buNone/>
             </a:pPr>
             <a:r>
               <a:rPr lang="en-US" sz="1600" dirty="0">
@@ -7193,20 +8324,41 @@
                 <a:ea typeface="Arial" pitchFamily="34" charset="-122"/>
                 <a:cs typeface="Arial" pitchFamily="34" charset="-120"/>
               </a:rPr>
-              <a:t>Provider Switching (Groq, Anthropic, Gemini)</a:t>
+              <a:t>• Provider Switching (Groq, Anthropic, Gemini)</a:t>
             </a:r>
             <a:endParaRPr lang="en-US" sz="1600" dirty="0"/>
           </a:p>
-          <a:p>
-            <a:pPr algn="l" marL="127000" indent="-127000">
+        </p:txBody>
+      </p:sp>
+      <p:sp>
+        <p:nvSpPr>
+          <p:cNvPr id="13" name="Text 11"/>
+          <p:cNvSpPr/>
+          <p:nvPr/>
+        </p:nvSpPr>
+        <p:spPr>
+          <a:xfrm>
+            <a:off x="761851" y="4683770"/>
+            <a:ext cx="8031682" cy="264021"/>
+          </a:xfrm>
+          <a:prstGeom prst="rect">
+            <a:avLst/>
+          </a:prstGeom>
+          <a:noFill/>
+          <a:ln/>
+        </p:spPr>
+        <p:txBody>
+          <a:bodyPr wrap="square" lIns="0" tIns="0" rIns="0" bIns="0" rtlCol="0" anchor="t"/>
+          <a:lstStyle/>
+          <a:p>
+            <a:pPr algn="l" indent="0" marL="0">
               <a:lnSpc>
                 <a:spcPts val="2080"/>
               </a:lnSpc>
               <a:spcAft>
                 <a:spcPts val="1000"/>
               </a:spcAft>
-              <a:buSzPct val="100000"/>
-              <a:buChar char="•"/>
+              <a:buNone/>
             </a:pPr>
             <a:r>
               <a:rPr lang="en-US" sz="1600" dirty="0">
@@ -7217,7 +8369,7 @@
                 <a:ea typeface="Arial" pitchFamily="34" charset="-122"/>
                 <a:cs typeface="Arial" pitchFamily="34" charset="-120"/>
               </a:rPr>
-              <a:t>Reliability Feedback</a:t>
+              <a:t>• Reliability Feedback</a:t>
             </a:r>
             <a:endParaRPr lang="en-US" sz="1600" dirty="0"/>
           </a:p>

</xml_diff>